<commit_message>
Version 4.6.5 Pro - Sistema Blindado Fase 7
</commit_message>
<xml_diff>
--- a/DOCUMENTOS/Presentación1.pptx
+++ b/DOCUMENTOS/Presentación1.pptx
@@ -14,6 +14,11 @@
     <p:sldId id="262" r:id="rId8"/>
     <p:sldId id="263" r:id="rId9"/>
     <p:sldId id="264" r:id="rId10"/>
+    <p:sldId id="265" r:id="rId11"/>
+    <p:sldId id="266" r:id="rId12"/>
+    <p:sldId id="267" r:id="rId13"/>
+    <p:sldId id="268" r:id="rId14"/>
+    <p:sldId id="269" r:id="rId15"/>
   </p:sldIdLst>
   <p:sldSz cx="12192000" cy="6858000"/>
   <p:notesSz cx="6858000" cy="9144000"/>
@@ -113,6 +118,28 @@
     </a:lvl9pPr>
   </p:defaultTextStyle>
   <p:extLst>
+    <p:ext uri="{521415D9-36F7-43E2-AB2F-B90AF26B5E84}">
+      <p14:sectionLst xmlns:p14="http://schemas.microsoft.com/office/powerpoint/2010/main">
+        <p14:section name="Sección predeterminada" id="{C69C7080-7B1E-40BF-B4ED-4C1CD27493C6}">
+          <p14:sldIdLst>
+            <p14:sldId id="256"/>
+            <p14:sldId id="258"/>
+            <p14:sldId id="257"/>
+            <p14:sldId id="259"/>
+            <p14:sldId id="260"/>
+            <p14:sldId id="261"/>
+            <p14:sldId id="262"/>
+            <p14:sldId id="263"/>
+            <p14:sldId id="264"/>
+            <p14:sldId id="265"/>
+            <p14:sldId id="266"/>
+            <p14:sldId id="267"/>
+            <p14:sldId id="268"/>
+            <p14:sldId id="269"/>
+          </p14:sldIdLst>
+        </p14:section>
+      </p14:sectionLst>
+    </p:ext>
     <p:ext uri="{EFAFB233-063F-42B5-8137-9DF3F51BA10A}">
       <p15:sldGuideLst xmlns:p15="http://schemas.microsoft.com/office/powerpoint/2012/main"/>
     </p:ext>
@@ -230,35 +257,35 @@
               <a:buNone/>
               <a:defRPr sz="2400"/>
             </a:lvl1pPr>
-            <a:lvl2pPr marL="457200" indent="0" algn="ctr">
+            <a:lvl2pPr marL="457206" indent="0" algn="ctr">
               <a:buNone/>
               <a:defRPr sz="2000"/>
             </a:lvl2pPr>
-            <a:lvl3pPr marL="914400" indent="0" algn="ctr">
+            <a:lvl3pPr marL="914411" indent="0" algn="ctr">
               <a:buNone/>
-              <a:defRPr sz="1800"/>
+              <a:defRPr sz="1801"/>
             </a:lvl3pPr>
-            <a:lvl4pPr marL="1371600" indent="0" algn="ctr">
+            <a:lvl4pPr marL="1371617" indent="0" algn="ctr">
               <a:buNone/>
               <a:defRPr sz="1600"/>
             </a:lvl4pPr>
-            <a:lvl5pPr marL="1828800" indent="0" algn="ctr">
+            <a:lvl5pPr marL="1828823" indent="0" algn="ctr">
               <a:buNone/>
               <a:defRPr sz="1600"/>
             </a:lvl5pPr>
-            <a:lvl6pPr marL="2286000" indent="0" algn="ctr">
+            <a:lvl6pPr marL="2286029" indent="0" algn="ctr">
               <a:buNone/>
               <a:defRPr sz="1600"/>
             </a:lvl6pPr>
-            <a:lvl7pPr marL="2743200" indent="0" algn="ctr">
+            <a:lvl7pPr marL="2743234" indent="0" algn="ctr">
               <a:buNone/>
               <a:defRPr sz="1600"/>
             </a:lvl7pPr>
-            <a:lvl8pPr marL="3200400" indent="0" algn="ctr">
+            <a:lvl8pPr marL="3200440" indent="0" algn="ctr">
               <a:buNone/>
               <a:defRPr sz="1600"/>
             </a:lvl8pPr>
-            <a:lvl9pPr marL="3657600" indent="0" algn="ctr">
+            <a:lvl9pPr marL="3657646" indent="0" algn="ctr">
               <a:buNone/>
               <a:defRPr sz="1600"/>
             </a:lvl9pPr>
@@ -295,7 +322,7 @@
           <a:p>
             <a:fld id="{277623FA-E2C1-4F72-86A8-23316B777576}" type="datetimeFigureOut">
               <a:rPr lang="es-PE" smtClean="0"/>
-              <a:t>8/09/2026</a:t>
+              <a:t>20/09/2026</a:t>
             </a:fld>
             <a:endParaRPr lang="es-PE"/>
           </a:p>
@@ -495,7 +522,7 @@
           <a:p>
             <a:fld id="{277623FA-E2C1-4F72-86A8-23316B777576}" type="datetimeFigureOut">
               <a:rPr lang="es-PE" smtClean="0"/>
-              <a:t>8/09/2026</a:t>
+              <a:t>20/09/2026</a:t>
             </a:fld>
             <a:endParaRPr lang="es-PE"/>
           </a:p>
@@ -603,7 +630,7 @@
         </p:nvSpPr>
         <p:spPr>
           <a:xfrm>
-            <a:off x="8724900" y="365125"/>
+            <a:off x="8724899" y="365125"/>
             <a:ext cx="2628900" cy="5811838"/>
           </a:xfrm>
         </p:spPr>
@@ -637,7 +664,7 @@
         </p:nvSpPr>
         <p:spPr>
           <a:xfrm>
-            <a:off x="838200" y="365125"/>
+            <a:off x="838199" y="365125"/>
             <a:ext cx="7734300" cy="5811838"/>
           </a:xfrm>
         </p:spPr>
@@ -705,7 +732,7 @@
           <a:p>
             <a:fld id="{277623FA-E2C1-4F72-86A8-23316B777576}" type="datetimeFigureOut">
               <a:rPr lang="es-PE" smtClean="0"/>
-              <a:t>8/09/2026</a:t>
+              <a:t>20/09/2026</a:t>
             </a:fld>
             <a:endParaRPr lang="es-PE"/>
           </a:p>
@@ -905,7 +932,7 @@
           <a:p>
             <a:fld id="{277623FA-E2C1-4F72-86A8-23316B777576}" type="datetimeFigureOut">
               <a:rPr lang="es-PE" smtClean="0"/>
-              <a:t>8/09/2026</a:t>
+              <a:t>20/09/2026</a:t>
             </a:fld>
             <a:endParaRPr lang="es-PE"/>
           </a:p>
@@ -1013,7 +1040,7 @@
         </p:nvSpPr>
         <p:spPr>
           <a:xfrm>
-            <a:off x="831850" y="1709738"/>
+            <a:off x="831852" y="1709738"/>
             <a:ext cx="10515600" cy="2852737"/>
           </a:xfrm>
         </p:spPr>
@@ -1051,7 +1078,7 @@
         </p:nvSpPr>
         <p:spPr>
           <a:xfrm>
-            <a:off x="831850" y="4589463"/>
+            <a:off x="831852" y="4589464"/>
             <a:ext cx="10515600" cy="1500187"/>
           </a:xfrm>
         </p:spPr>
@@ -1068,7 +1095,7 @@
                 </a:solidFill>
               </a:defRPr>
             </a:lvl1pPr>
-            <a:lvl2pPr marL="457200" indent="0">
+            <a:lvl2pPr marL="457206" indent="0">
               <a:buNone/>
               <a:defRPr sz="2000">
                 <a:solidFill>
@@ -1078,9 +1105,9 @@
                 </a:solidFill>
               </a:defRPr>
             </a:lvl2pPr>
-            <a:lvl3pPr marL="914400" indent="0">
+            <a:lvl3pPr marL="914411" indent="0">
               <a:buNone/>
-              <a:defRPr sz="1800">
+              <a:defRPr sz="1801">
                 <a:solidFill>
                   <a:schemeClr val="tx1">
                     <a:tint val="75000"/>
@@ -1088,7 +1115,7 @@
                 </a:solidFill>
               </a:defRPr>
             </a:lvl3pPr>
-            <a:lvl4pPr marL="1371600" indent="0">
+            <a:lvl4pPr marL="1371617" indent="0">
               <a:buNone/>
               <a:defRPr sz="1600">
                 <a:solidFill>
@@ -1098,7 +1125,7 @@
                 </a:solidFill>
               </a:defRPr>
             </a:lvl4pPr>
-            <a:lvl5pPr marL="1828800" indent="0">
+            <a:lvl5pPr marL="1828823" indent="0">
               <a:buNone/>
               <a:defRPr sz="1600">
                 <a:solidFill>
@@ -1108,7 +1135,7 @@
                 </a:solidFill>
               </a:defRPr>
             </a:lvl5pPr>
-            <a:lvl6pPr marL="2286000" indent="0">
+            <a:lvl6pPr marL="2286029" indent="0">
               <a:buNone/>
               <a:defRPr sz="1600">
                 <a:solidFill>
@@ -1118,7 +1145,7 @@
                 </a:solidFill>
               </a:defRPr>
             </a:lvl6pPr>
-            <a:lvl7pPr marL="2743200" indent="0">
+            <a:lvl7pPr marL="2743234" indent="0">
               <a:buNone/>
               <a:defRPr sz="1600">
                 <a:solidFill>
@@ -1128,7 +1155,7 @@
                 </a:solidFill>
               </a:defRPr>
             </a:lvl7pPr>
-            <a:lvl8pPr marL="3200400" indent="0">
+            <a:lvl8pPr marL="3200440" indent="0">
               <a:buNone/>
               <a:defRPr sz="1600">
                 <a:solidFill>
@@ -1138,7 +1165,7 @@
                 </a:solidFill>
               </a:defRPr>
             </a:lvl8pPr>
-            <a:lvl9pPr marL="3657600" indent="0">
+            <a:lvl9pPr marL="3657646" indent="0">
               <a:buNone/>
               <a:defRPr sz="1600">
                 <a:solidFill>
@@ -1181,7 +1208,7 @@
           <a:p>
             <a:fld id="{277623FA-E2C1-4F72-86A8-23316B777576}" type="datetimeFigureOut">
               <a:rPr lang="es-PE" smtClean="0"/>
-              <a:t>8/09/2026</a:t>
+              <a:t>20/09/2026</a:t>
             </a:fld>
             <a:endParaRPr lang="es-PE"/>
           </a:p>
@@ -1318,7 +1345,7 @@
         </p:nvSpPr>
         <p:spPr>
           <a:xfrm>
-            <a:off x="838200" y="1825625"/>
+            <a:off x="838201" y="1825625"/>
             <a:ext cx="5181600" cy="4351338"/>
           </a:xfrm>
         </p:spPr>
@@ -1381,7 +1408,7 @@
         </p:nvSpPr>
         <p:spPr>
           <a:xfrm>
-            <a:off x="6172200" y="1825625"/>
+            <a:off x="6172201" y="1825625"/>
             <a:ext cx="5181600" cy="4351338"/>
           </a:xfrm>
         </p:spPr>
@@ -1449,7 +1476,7 @@
           <a:p>
             <a:fld id="{277623FA-E2C1-4F72-86A8-23316B777576}" type="datetimeFigureOut">
               <a:rPr lang="es-PE" smtClean="0"/>
-              <a:t>8/09/2026</a:t>
+              <a:t>20/09/2026</a:t>
             </a:fld>
             <a:endParaRPr lang="es-PE"/>
           </a:p>
@@ -1557,7 +1584,7 @@
         </p:nvSpPr>
         <p:spPr>
           <a:xfrm>
-            <a:off x="839788" y="365125"/>
+            <a:off x="839789" y="365125"/>
             <a:ext cx="10515600" cy="1325563"/>
           </a:xfrm>
         </p:spPr>
@@ -1591,7 +1618,7 @@
         </p:nvSpPr>
         <p:spPr>
           <a:xfrm>
-            <a:off x="839788" y="1681163"/>
+            <a:off x="839789" y="1681163"/>
             <a:ext cx="5157787" cy="823912"/>
           </a:xfrm>
         </p:spPr>
@@ -1602,35 +1629,35 @@
               <a:buNone/>
               <a:defRPr sz="2400" b="1"/>
             </a:lvl1pPr>
-            <a:lvl2pPr marL="457200" indent="0">
+            <a:lvl2pPr marL="457206" indent="0">
               <a:buNone/>
               <a:defRPr sz="2000" b="1"/>
             </a:lvl2pPr>
-            <a:lvl3pPr marL="914400" indent="0">
+            <a:lvl3pPr marL="914411" indent="0">
               <a:buNone/>
-              <a:defRPr sz="1800" b="1"/>
+              <a:defRPr sz="1801" b="1"/>
             </a:lvl3pPr>
-            <a:lvl4pPr marL="1371600" indent="0">
+            <a:lvl4pPr marL="1371617" indent="0">
               <a:buNone/>
               <a:defRPr sz="1600" b="1"/>
             </a:lvl4pPr>
-            <a:lvl5pPr marL="1828800" indent="0">
+            <a:lvl5pPr marL="1828823" indent="0">
               <a:buNone/>
               <a:defRPr sz="1600" b="1"/>
             </a:lvl5pPr>
-            <a:lvl6pPr marL="2286000" indent="0">
+            <a:lvl6pPr marL="2286029" indent="0">
               <a:buNone/>
               <a:defRPr sz="1600" b="1"/>
             </a:lvl6pPr>
-            <a:lvl7pPr marL="2743200" indent="0">
+            <a:lvl7pPr marL="2743234" indent="0">
               <a:buNone/>
               <a:defRPr sz="1600" b="1"/>
             </a:lvl7pPr>
-            <a:lvl8pPr marL="3200400" indent="0">
+            <a:lvl8pPr marL="3200440" indent="0">
               <a:buNone/>
               <a:defRPr sz="1600" b="1"/>
             </a:lvl8pPr>
-            <a:lvl9pPr marL="3657600" indent="0">
+            <a:lvl9pPr marL="3657646" indent="0">
               <a:buNone/>
               <a:defRPr sz="1600" b="1"/>
             </a:lvl9pPr>
@@ -1662,7 +1689,7 @@
         </p:nvSpPr>
         <p:spPr>
           <a:xfrm>
-            <a:off x="839788" y="2505075"/>
+            <a:off x="839789" y="2505076"/>
             <a:ext cx="5157787" cy="3684588"/>
           </a:xfrm>
         </p:spPr>
@@ -1725,7 +1752,7 @@
         </p:nvSpPr>
         <p:spPr>
           <a:xfrm>
-            <a:off x="6172200" y="1681163"/>
+            <a:off x="6172202" y="1681163"/>
             <a:ext cx="5183188" cy="823912"/>
           </a:xfrm>
         </p:spPr>
@@ -1736,35 +1763,35 @@
               <a:buNone/>
               <a:defRPr sz="2400" b="1"/>
             </a:lvl1pPr>
-            <a:lvl2pPr marL="457200" indent="0">
+            <a:lvl2pPr marL="457206" indent="0">
               <a:buNone/>
               <a:defRPr sz="2000" b="1"/>
             </a:lvl2pPr>
-            <a:lvl3pPr marL="914400" indent="0">
+            <a:lvl3pPr marL="914411" indent="0">
               <a:buNone/>
-              <a:defRPr sz="1800" b="1"/>
+              <a:defRPr sz="1801" b="1"/>
             </a:lvl3pPr>
-            <a:lvl4pPr marL="1371600" indent="0">
+            <a:lvl4pPr marL="1371617" indent="0">
               <a:buNone/>
               <a:defRPr sz="1600" b="1"/>
             </a:lvl4pPr>
-            <a:lvl5pPr marL="1828800" indent="0">
+            <a:lvl5pPr marL="1828823" indent="0">
               <a:buNone/>
               <a:defRPr sz="1600" b="1"/>
             </a:lvl5pPr>
-            <a:lvl6pPr marL="2286000" indent="0">
+            <a:lvl6pPr marL="2286029" indent="0">
               <a:buNone/>
               <a:defRPr sz="1600" b="1"/>
             </a:lvl6pPr>
-            <a:lvl7pPr marL="2743200" indent="0">
+            <a:lvl7pPr marL="2743234" indent="0">
               <a:buNone/>
               <a:defRPr sz="1600" b="1"/>
             </a:lvl7pPr>
-            <a:lvl8pPr marL="3200400" indent="0">
+            <a:lvl8pPr marL="3200440" indent="0">
               <a:buNone/>
               <a:defRPr sz="1600" b="1"/>
             </a:lvl8pPr>
-            <a:lvl9pPr marL="3657600" indent="0">
+            <a:lvl9pPr marL="3657646" indent="0">
               <a:buNone/>
               <a:defRPr sz="1600" b="1"/>
             </a:lvl9pPr>
@@ -1796,7 +1823,7 @@
         </p:nvSpPr>
         <p:spPr>
           <a:xfrm>
-            <a:off x="6172200" y="2505075"/>
+            <a:off x="6172202" y="2505076"/>
             <a:ext cx="5183188" cy="3684588"/>
           </a:xfrm>
         </p:spPr>
@@ -1864,7 +1891,7 @@
           <a:p>
             <a:fld id="{277623FA-E2C1-4F72-86A8-23316B777576}" type="datetimeFigureOut">
               <a:rPr lang="es-PE" smtClean="0"/>
-              <a:t>8/09/2026</a:t>
+              <a:t>20/09/2026</a:t>
             </a:fld>
             <a:endParaRPr lang="es-PE"/>
           </a:p>
@@ -2006,7 +2033,7 @@
           <a:p>
             <a:fld id="{277623FA-E2C1-4F72-86A8-23316B777576}" type="datetimeFigureOut">
               <a:rPr lang="es-PE" smtClean="0"/>
-              <a:t>8/09/2026</a:t>
+              <a:t>20/09/2026</a:t>
             </a:fld>
             <a:endParaRPr lang="es-PE"/>
           </a:p>
@@ -2119,7 +2146,7 @@
           <a:p>
             <a:fld id="{277623FA-E2C1-4F72-86A8-23316B777576}" type="datetimeFigureOut">
               <a:rPr lang="es-PE" smtClean="0"/>
-              <a:t>8/09/2026</a:t>
+              <a:t>20/09/2026</a:t>
             </a:fld>
             <a:endParaRPr lang="es-PE"/>
           </a:p>
@@ -2227,8 +2254,8 @@
         </p:nvSpPr>
         <p:spPr>
           <a:xfrm>
-            <a:off x="839788" y="457200"/>
-            <a:ext cx="3932237" cy="1600200"/>
+            <a:off x="839790" y="457200"/>
+            <a:ext cx="3932236" cy="1600200"/>
           </a:xfrm>
         </p:spPr>
         <p:txBody>
@@ -2266,7 +2293,7 @@
         <p:spPr>
           <a:xfrm>
             <a:off x="5183188" y="987425"/>
-            <a:ext cx="6172200" cy="4873625"/>
+            <a:ext cx="6172201" cy="4873625"/>
           </a:xfrm>
         </p:spPr>
         <p:txBody>
@@ -2356,8 +2383,8 @@
         </p:nvSpPr>
         <p:spPr>
           <a:xfrm>
-            <a:off x="839788" y="2057400"/>
-            <a:ext cx="3932237" cy="3811588"/>
+            <a:off x="839790" y="2057400"/>
+            <a:ext cx="3932236" cy="3811588"/>
           </a:xfrm>
         </p:spPr>
         <p:txBody>
@@ -2367,37 +2394,37 @@
               <a:buNone/>
               <a:defRPr sz="1600"/>
             </a:lvl1pPr>
-            <a:lvl2pPr marL="457200" indent="0">
+            <a:lvl2pPr marL="457206" indent="0">
               <a:buNone/>
-              <a:defRPr sz="1400"/>
+              <a:defRPr sz="1401"/>
             </a:lvl2pPr>
-            <a:lvl3pPr marL="914400" indent="0">
+            <a:lvl3pPr marL="914411" indent="0">
               <a:buNone/>
               <a:defRPr sz="1200"/>
             </a:lvl3pPr>
-            <a:lvl4pPr marL="1371600" indent="0">
+            <a:lvl4pPr marL="1371617" indent="0">
               <a:buNone/>
-              <a:defRPr sz="1000"/>
+              <a:defRPr sz="1001"/>
             </a:lvl4pPr>
-            <a:lvl5pPr marL="1828800" indent="0">
+            <a:lvl5pPr marL="1828823" indent="0">
               <a:buNone/>
-              <a:defRPr sz="1000"/>
+              <a:defRPr sz="1001"/>
             </a:lvl5pPr>
-            <a:lvl6pPr marL="2286000" indent="0">
+            <a:lvl6pPr marL="2286029" indent="0">
               <a:buNone/>
-              <a:defRPr sz="1000"/>
+              <a:defRPr sz="1001"/>
             </a:lvl6pPr>
-            <a:lvl7pPr marL="2743200" indent="0">
+            <a:lvl7pPr marL="2743234" indent="0">
               <a:buNone/>
-              <a:defRPr sz="1000"/>
+              <a:defRPr sz="1001"/>
             </a:lvl7pPr>
-            <a:lvl8pPr marL="3200400" indent="0">
+            <a:lvl8pPr marL="3200440" indent="0">
               <a:buNone/>
-              <a:defRPr sz="1000"/>
+              <a:defRPr sz="1001"/>
             </a:lvl8pPr>
-            <a:lvl9pPr marL="3657600" indent="0">
+            <a:lvl9pPr marL="3657646" indent="0">
               <a:buNone/>
-              <a:defRPr sz="1000"/>
+              <a:defRPr sz="1001"/>
             </a:lvl9pPr>
           </a:lstStyle>
           <a:p>
@@ -2432,7 +2459,7 @@
           <a:p>
             <a:fld id="{277623FA-E2C1-4F72-86A8-23316B777576}" type="datetimeFigureOut">
               <a:rPr lang="es-PE" smtClean="0"/>
-              <a:t>8/09/2026</a:t>
+              <a:t>20/09/2026</a:t>
             </a:fld>
             <a:endParaRPr lang="es-PE"/>
           </a:p>
@@ -2540,8 +2567,8 @@
         </p:nvSpPr>
         <p:spPr>
           <a:xfrm>
-            <a:off x="839788" y="457200"/>
-            <a:ext cx="3932237" cy="1600200"/>
+            <a:off x="839790" y="457200"/>
+            <a:ext cx="3932236" cy="1600200"/>
           </a:xfrm>
         </p:spPr>
         <p:txBody>
@@ -2579,7 +2606,7 @@
         <p:spPr>
           <a:xfrm>
             <a:off x="5183188" y="987425"/>
-            <a:ext cx="6172200" cy="4873625"/>
+            <a:ext cx="6172201" cy="4873625"/>
           </a:xfrm>
         </p:spPr>
         <p:txBody>
@@ -2589,35 +2616,35 @@
               <a:buNone/>
               <a:defRPr sz="3200"/>
             </a:lvl1pPr>
-            <a:lvl2pPr marL="457200" indent="0">
+            <a:lvl2pPr marL="457206" indent="0">
               <a:buNone/>
               <a:defRPr sz="2800"/>
             </a:lvl2pPr>
-            <a:lvl3pPr marL="914400" indent="0">
+            <a:lvl3pPr marL="914411" indent="0">
               <a:buNone/>
               <a:defRPr sz="2400"/>
             </a:lvl3pPr>
-            <a:lvl4pPr marL="1371600" indent="0">
+            <a:lvl4pPr marL="1371617" indent="0">
               <a:buNone/>
               <a:defRPr sz="2000"/>
             </a:lvl4pPr>
-            <a:lvl5pPr marL="1828800" indent="0">
+            <a:lvl5pPr marL="1828823" indent="0">
               <a:buNone/>
               <a:defRPr sz="2000"/>
             </a:lvl5pPr>
-            <a:lvl6pPr marL="2286000" indent="0">
+            <a:lvl6pPr marL="2286029" indent="0">
               <a:buNone/>
               <a:defRPr sz="2000"/>
             </a:lvl6pPr>
-            <a:lvl7pPr marL="2743200" indent="0">
+            <a:lvl7pPr marL="2743234" indent="0">
               <a:buNone/>
               <a:defRPr sz="2000"/>
             </a:lvl7pPr>
-            <a:lvl8pPr marL="3200400" indent="0">
+            <a:lvl8pPr marL="3200440" indent="0">
               <a:buNone/>
               <a:defRPr sz="2000"/>
             </a:lvl8pPr>
-            <a:lvl9pPr marL="3657600" indent="0">
+            <a:lvl9pPr marL="3657646" indent="0">
               <a:buNone/>
               <a:defRPr sz="2000"/>
             </a:lvl9pPr>
@@ -2645,8 +2672,8 @@
         </p:nvSpPr>
         <p:spPr>
           <a:xfrm>
-            <a:off x="839788" y="2057400"/>
-            <a:ext cx="3932237" cy="3811588"/>
+            <a:off x="839790" y="2057400"/>
+            <a:ext cx="3932236" cy="3811588"/>
           </a:xfrm>
         </p:spPr>
         <p:txBody>
@@ -2656,37 +2683,37 @@
               <a:buNone/>
               <a:defRPr sz="1600"/>
             </a:lvl1pPr>
-            <a:lvl2pPr marL="457200" indent="0">
+            <a:lvl2pPr marL="457206" indent="0">
               <a:buNone/>
-              <a:defRPr sz="1400"/>
+              <a:defRPr sz="1401"/>
             </a:lvl2pPr>
-            <a:lvl3pPr marL="914400" indent="0">
+            <a:lvl3pPr marL="914411" indent="0">
               <a:buNone/>
               <a:defRPr sz="1200"/>
             </a:lvl3pPr>
-            <a:lvl4pPr marL="1371600" indent="0">
+            <a:lvl4pPr marL="1371617" indent="0">
               <a:buNone/>
-              <a:defRPr sz="1000"/>
+              <a:defRPr sz="1001"/>
             </a:lvl4pPr>
-            <a:lvl5pPr marL="1828800" indent="0">
+            <a:lvl5pPr marL="1828823" indent="0">
               <a:buNone/>
-              <a:defRPr sz="1000"/>
+              <a:defRPr sz="1001"/>
             </a:lvl5pPr>
-            <a:lvl6pPr marL="2286000" indent="0">
+            <a:lvl6pPr marL="2286029" indent="0">
               <a:buNone/>
-              <a:defRPr sz="1000"/>
+              <a:defRPr sz="1001"/>
             </a:lvl6pPr>
-            <a:lvl7pPr marL="2743200" indent="0">
+            <a:lvl7pPr marL="2743234" indent="0">
               <a:buNone/>
-              <a:defRPr sz="1000"/>
+              <a:defRPr sz="1001"/>
             </a:lvl7pPr>
-            <a:lvl8pPr marL="3200400" indent="0">
+            <a:lvl8pPr marL="3200440" indent="0">
               <a:buNone/>
-              <a:defRPr sz="1000"/>
+              <a:defRPr sz="1001"/>
             </a:lvl8pPr>
-            <a:lvl9pPr marL="3657600" indent="0">
+            <a:lvl9pPr marL="3657646" indent="0">
               <a:buNone/>
-              <a:defRPr sz="1000"/>
+              <a:defRPr sz="1001"/>
             </a:lvl9pPr>
           </a:lstStyle>
           <a:p>
@@ -2721,7 +2748,7 @@
           <a:p>
             <a:fld id="{277623FA-E2C1-4F72-86A8-23316B777576}" type="datetimeFigureOut">
               <a:rPr lang="es-PE" smtClean="0"/>
-              <a:t>8/09/2026</a:t>
+              <a:t>20/09/2026</a:t>
             </a:fld>
             <a:endParaRPr lang="es-PE"/>
           </a:p>
@@ -2834,7 +2861,7 @@
         </p:nvSpPr>
         <p:spPr>
           <a:xfrm>
-            <a:off x="838200" y="365125"/>
+            <a:off x="838202" y="365125"/>
             <a:ext cx="10515600" cy="1325563"/>
           </a:xfrm>
           <a:prstGeom prst="rect">
@@ -2873,7 +2900,7 @@
         </p:nvSpPr>
         <p:spPr>
           <a:xfrm>
-            <a:off x="838200" y="1825625"/>
+            <a:off x="838202" y="1825625"/>
             <a:ext cx="10515600" cy="4351338"/>
           </a:xfrm>
           <a:prstGeom prst="rect">
@@ -2941,7 +2968,7 @@
         </p:nvSpPr>
         <p:spPr>
           <a:xfrm>
-            <a:off x="838200" y="6356350"/>
+            <a:off x="838201" y="6356351"/>
             <a:ext cx="2743200" cy="365125"/>
           </a:xfrm>
           <a:prstGeom prst="rect">
@@ -2964,7 +2991,7 @@
           <a:p>
             <a:fld id="{277623FA-E2C1-4F72-86A8-23316B777576}" type="datetimeFigureOut">
               <a:rPr lang="es-PE" smtClean="0"/>
-              <a:t>8/09/2026</a:t>
+              <a:t>20/09/2026</a:t>
             </a:fld>
             <a:endParaRPr lang="es-PE"/>
           </a:p>
@@ -2988,7 +3015,7 @@
         </p:nvSpPr>
         <p:spPr>
           <a:xfrm>
-            <a:off x="4038600" y="6356350"/>
+            <a:off x="4038602" y="6356351"/>
             <a:ext cx="4114800" cy="365125"/>
           </a:xfrm>
           <a:prstGeom prst="rect">
@@ -3031,7 +3058,7 @@
         </p:nvSpPr>
         <p:spPr>
           <a:xfrm>
-            <a:off x="8610600" y="6356350"/>
+            <a:off x="8610601" y="6356351"/>
             <a:ext cx="2743200" cy="365125"/>
           </a:xfrm>
           <a:prstGeom prst="rect">
@@ -3083,7 +3110,7 @@
   </p:sldLayoutIdLst>
   <p:txStyles>
     <p:titleStyle>
-      <a:lvl1pPr algn="l" defTabSz="914400" rtl="0" eaLnBrk="1" latinLnBrk="0" hangingPunct="1">
+      <a:lvl1pPr algn="l" defTabSz="914411" rtl="0" eaLnBrk="1" latinLnBrk="0" hangingPunct="1">
         <a:lnSpc>
           <a:spcPct val="90000"/>
         </a:lnSpc>
@@ -3102,12 +3129,12 @@
       </a:lvl1pPr>
     </p:titleStyle>
     <p:bodyStyle>
-      <a:lvl1pPr marL="228600" indent="-228600" algn="l" defTabSz="914400" rtl="0" eaLnBrk="1" latinLnBrk="0" hangingPunct="1">
+      <a:lvl1pPr marL="228604" indent="-228604" algn="l" defTabSz="914411" rtl="0" eaLnBrk="1" latinLnBrk="0" hangingPunct="1">
         <a:lnSpc>
           <a:spcPct val="90000"/>
         </a:lnSpc>
         <a:spcBef>
-          <a:spcPts val="1000"/>
+          <a:spcPts val="1001"/>
         </a:spcBef>
         <a:buFont typeface="Arial" panose="020B0604020202020204" pitchFamily="34" charset="0"/>
         <a:buChar char="•"/>
@@ -3120,7 +3147,7 @@
           <a:cs typeface="+mn-cs"/>
         </a:defRPr>
       </a:lvl1pPr>
-      <a:lvl2pPr marL="685800" indent="-228600" algn="l" defTabSz="914400" rtl="0" eaLnBrk="1" latinLnBrk="0" hangingPunct="1">
+      <a:lvl2pPr marL="685809" indent="-228604" algn="l" defTabSz="914411" rtl="0" eaLnBrk="1" latinLnBrk="0" hangingPunct="1">
         <a:lnSpc>
           <a:spcPct val="90000"/>
         </a:lnSpc>
@@ -3138,7 +3165,7 @@
           <a:cs typeface="+mn-cs"/>
         </a:defRPr>
       </a:lvl2pPr>
-      <a:lvl3pPr marL="1143000" indent="-228600" algn="l" defTabSz="914400" rtl="0" eaLnBrk="1" latinLnBrk="0" hangingPunct="1">
+      <a:lvl3pPr marL="1143015" indent="-228604" algn="l" defTabSz="914411" rtl="0" eaLnBrk="1" latinLnBrk="0" hangingPunct="1">
         <a:lnSpc>
           <a:spcPct val="90000"/>
         </a:lnSpc>
@@ -3156,7 +3183,7 @@
           <a:cs typeface="+mn-cs"/>
         </a:defRPr>
       </a:lvl3pPr>
-      <a:lvl4pPr marL="1600200" indent="-228600" algn="l" defTabSz="914400" rtl="0" eaLnBrk="1" latinLnBrk="0" hangingPunct="1">
+      <a:lvl4pPr marL="1600221" indent="-228604" algn="l" defTabSz="914411" rtl="0" eaLnBrk="1" latinLnBrk="0" hangingPunct="1">
         <a:lnSpc>
           <a:spcPct val="90000"/>
         </a:lnSpc>
@@ -3165,7 +3192,7 @@
         </a:spcBef>
         <a:buFont typeface="Arial" panose="020B0604020202020204" pitchFamily="34" charset="0"/>
         <a:buChar char="•"/>
-        <a:defRPr sz="1800" kern="1200">
+        <a:defRPr sz="1801" kern="1200">
           <a:solidFill>
             <a:schemeClr val="tx1"/>
           </a:solidFill>
@@ -3174,7 +3201,7 @@
           <a:cs typeface="+mn-cs"/>
         </a:defRPr>
       </a:lvl4pPr>
-      <a:lvl5pPr marL="2057400" indent="-228600" algn="l" defTabSz="914400" rtl="0" eaLnBrk="1" latinLnBrk="0" hangingPunct="1">
+      <a:lvl5pPr marL="2057427" indent="-228604" algn="l" defTabSz="914411" rtl="0" eaLnBrk="1" latinLnBrk="0" hangingPunct="1">
         <a:lnSpc>
           <a:spcPct val="90000"/>
         </a:lnSpc>
@@ -3183,7 +3210,7 @@
         </a:spcBef>
         <a:buFont typeface="Arial" panose="020B0604020202020204" pitchFamily="34" charset="0"/>
         <a:buChar char="•"/>
-        <a:defRPr sz="1800" kern="1200">
+        <a:defRPr sz="1801" kern="1200">
           <a:solidFill>
             <a:schemeClr val="tx1"/>
           </a:solidFill>
@@ -3192,7 +3219,7 @@
           <a:cs typeface="+mn-cs"/>
         </a:defRPr>
       </a:lvl5pPr>
-      <a:lvl6pPr marL="2514600" indent="-228600" algn="l" defTabSz="914400" rtl="0" eaLnBrk="1" latinLnBrk="0" hangingPunct="1">
+      <a:lvl6pPr marL="2514632" indent="-228604" algn="l" defTabSz="914411" rtl="0" eaLnBrk="1" latinLnBrk="0" hangingPunct="1">
         <a:lnSpc>
           <a:spcPct val="90000"/>
         </a:lnSpc>
@@ -3201,7 +3228,7 @@
         </a:spcBef>
         <a:buFont typeface="Arial" panose="020B0604020202020204" pitchFamily="34" charset="0"/>
         <a:buChar char="•"/>
-        <a:defRPr sz="1800" kern="1200">
+        <a:defRPr sz="1801" kern="1200">
           <a:solidFill>
             <a:schemeClr val="tx1"/>
           </a:solidFill>
@@ -3210,7 +3237,7 @@
           <a:cs typeface="+mn-cs"/>
         </a:defRPr>
       </a:lvl6pPr>
-      <a:lvl7pPr marL="2971800" indent="-228600" algn="l" defTabSz="914400" rtl="0" eaLnBrk="1" latinLnBrk="0" hangingPunct="1">
+      <a:lvl7pPr marL="2971838" indent="-228604" algn="l" defTabSz="914411" rtl="0" eaLnBrk="1" latinLnBrk="0" hangingPunct="1">
         <a:lnSpc>
           <a:spcPct val="90000"/>
         </a:lnSpc>
@@ -3219,7 +3246,7 @@
         </a:spcBef>
         <a:buFont typeface="Arial" panose="020B0604020202020204" pitchFamily="34" charset="0"/>
         <a:buChar char="•"/>
-        <a:defRPr sz="1800" kern="1200">
+        <a:defRPr sz="1801" kern="1200">
           <a:solidFill>
             <a:schemeClr val="tx1"/>
           </a:solidFill>
@@ -3228,7 +3255,7 @@
           <a:cs typeface="+mn-cs"/>
         </a:defRPr>
       </a:lvl7pPr>
-      <a:lvl8pPr marL="3429000" indent="-228600" algn="l" defTabSz="914400" rtl="0" eaLnBrk="1" latinLnBrk="0" hangingPunct="1">
+      <a:lvl8pPr marL="3429044" indent="-228604" algn="l" defTabSz="914411" rtl="0" eaLnBrk="1" latinLnBrk="0" hangingPunct="1">
         <a:lnSpc>
           <a:spcPct val="90000"/>
         </a:lnSpc>
@@ -3237,7 +3264,7 @@
         </a:spcBef>
         <a:buFont typeface="Arial" panose="020B0604020202020204" pitchFamily="34" charset="0"/>
         <a:buChar char="•"/>
-        <a:defRPr sz="1800" kern="1200">
+        <a:defRPr sz="1801" kern="1200">
           <a:solidFill>
             <a:schemeClr val="tx1"/>
           </a:solidFill>
@@ -3246,7 +3273,7 @@
           <a:cs typeface="+mn-cs"/>
         </a:defRPr>
       </a:lvl8pPr>
-      <a:lvl9pPr marL="3886200" indent="-228600" algn="l" defTabSz="914400" rtl="0" eaLnBrk="1" latinLnBrk="0" hangingPunct="1">
+      <a:lvl9pPr marL="3886249" indent="-228604" algn="l" defTabSz="914411" rtl="0" eaLnBrk="1" latinLnBrk="0" hangingPunct="1">
         <a:lnSpc>
           <a:spcPct val="90000"/>
         </a:lnSpc>
@@ -3255,7 +3282,7 @@
         </a:spcBef>
         <a:buFont typeface="Arial" panose="020B0604020202020204" pitchFamily="34" charset="0"/>
         <a:buChar char="•"/>
-        <a:defRPr sz="1800" kern="1200">
+        <a:defRPr sz="1801" kern="1200">
           <a:solidFill>
             <a:schemeClr val="tx1"/>
           </a:solidFill>
@@ -3269,8 +3296,8 @@
       <a:defPPr>
         <a:defRPr lang="es-PE"/>
       </a:defPPr>
-      <a:lvl1pPr marL="0" algn="l" defTabSz="914400" rtl="0" eaLnBrk="1" latinLnBrk="0" hangingPunct="1">
-        <a:defRPr sz="1800" kern="1200">
+      <a:lvl1pPr marL="0" algn="l" defTabSz="914411" rtl="0" eaLnBrk="1" latinLnBrk="0" hangingPunct="1">
+        <a:defRPr sz="1801" kern="1200">
           <a:solidFill>
             <a:schemeClr val="tx1"/>
           </a:solidFill>
@@ -3279,8 +3306,8 @@
           <a:cs typeface="+mn-cs"/>
         </a:defRPr>
       </a:lvl1pPr>
-      <a:lvl2pPr marL="457200" algn="l" defTabSz="914400" rtl="0" eaLnBrk="1" latinLnBrk="0" hangingPunct="1">
-        <a:defRPr sz="1800" kern="1200">
+      <a:lvl2pPr marL="457206" algn="l" defTabSz="914411" rtl="0" eaLnBrk="1" latinLnBrk="0" hangingPunct="1">
+        <a:defRPr sz="1801" kern="1200">
           <a:solidFill>
             <a:schemeClr val="tx1"/>
           </a:solidFill>
@@ -3289,8 +3316,8 @@
           <a:cs typeface="+mn-cs"/>
         </a:defRPr>
       </a:lvl2pPr>
-      <a:lvl3pPr marL="914400" algn="l" defTabSz="914400" rtl="0" eaLnBrk="1" latinLnBrk="0" hangingPunct="1">
-        <a:defRPr sz="1800" kern="1200">
+      <a:lvl3pPr marL="914411" algn="l" defTabSz="914411" rtl="0" eaLnBrk="1" latinLnBrk="0" hangingPunct="1">
+        <a:defRPr sz="1801" kern="1200">
           <a:solidFill>
             <a:schemeClr val="tx1"/>
           </a:solidFill>
@@ -3299,8 +3326,8 @@
           <a:cs typeface="+mn-cs"/>
         </a:defRPr>
       </a:lvl3pPr>
-      <a:lvl4pPr marL="1371600" algn="l" defTabSz="914400" rtl="0" eaLnBrk="1" latinLnBrk="0" hangingPunct="1">
-        <a:defRPr sz="1800" kern="1200">
+      <a:lvl4pPr marL="1371617" algn="l" defTabSz="914411" rtl="0" eaLnBrk="1" latinLnBrk="0" hangingPunct="1">
+        <a:defRPr sz="1801" kern="1200">
           <a:solidFill>
             <a:schemeClr val="tx1"/>
           </a:solidFill>
@@ -3309,8 +3336,8 @@
           <a:cs typeface="+mn-cs"/>
         </a:defRPr>
       </a:lvl4pPr>
-      <a:lvl5pPr marL="1828800" algn="l" defTabSz="914400" rtl="0" eaLnBrk="1" latinLnBrk="0" hangingPunct="1">
-        <a:defRPr sz="1800" kern="1200">
+      <a:lvl5pPr marL="1828823" algn="l" defTabSz="914411" rtl="0" eaLnBrk="1" latinLnBrk="0" hangingPunct="1">
+        <a:defRPr sz="1801" kern="1200">
           <a:solidFill>
             <a:schemeClr val="tx1"/>
           </a:solidFill>
@@ -3319,8 +3346,8 @@
           <a:cs typeface="+mn-cs"/>
         </a:defRPr>
       </a:lvl5pPr>
-      <a:lvl6pPr marL="2286000" algn="l" defTabSz="914400" rtl="0" eaLnBrk="1" latinLnBrk="0" hangingPunct="1">
-        <a:defRPr sz="1800" kern="1200">
+      <a:lvl6pPr marL="2286029" algn="l" defTabSz="914411" rtl="0" eaLnBrk="1" latinLnBrk="0" hangingPunct="1">
+        <a:defRPr sz="1801" kern="1200">
           <a:solidFill>
             <a:schemeClr val="tx1"/>
           </a:solidFill>
@@ -3329,8 +3356,8 @@
           <a:cs typeface="+mn-cs"/>
         </a:defRPr>
       </a:lvl6pPr>
-      <a:lvl7pPr marL="2743200" algn="l" defTabSz="914400" rtl="0" eaLnBrk="1" latinLnBrk="0" hangingPunct="1">
-        <a:defRPr sz="1800" kern="1200">
+      <a:lvl7pPr marL="2743234" algn="l" defTabSz="914411" rtl="0" eaLnBrk="1" latinLnBrk="0" hangingPunct="1">
+        <a:defRPr sz="1801" kern="1200">
           <a:solidFill>
             <a:schemeClr val="tx1"/>
           </a:solidFill>
@@ -3339,8 +3366,8 @@
           <a:cs typeface="+mn-cs"/>
         </a:defRPr>
       </a:lvl7pPr>
-      <a:lvl8pPr marL="3200400" algn="l" defTabSz="914400" rtl="0" eaLnBrk="1" latinLnBrk="0" hangingPunct="1">
-        <a:defRPr sz="1800" kern="1200">
+      <a:lvl8pPr marL="3200440" algn="l" defTabSz="914411" rtl="0" eaLnBrk="1" latinLnBrk="0" hangingPunct="1">
+        <a:defRPr sz="1801" kern="1200">
           <a:solidFill>
             <a:schemeClr val="tx1"/>
           </a:solidFill>
@@ -3349,8 +3376,8 @@
           <a:cs typeface="+mn-cs"/>
         </a:defRPr>
       </a:lvl8pPr>
-      <a:lvl9pPr marL="3657600" algn="l" defTabSz="914400" rtl="0" eaLnBrk="1" latinLnBrk="0" hangingPunct="1">
-        <a:defRPr sz="1800" kern="1200">
+      <a:lvl9pPr marL="3657646" algn="l" defTabSz="914411" rtl="0" eaLnBrk="1" latinLnBrk="0" hangingPunct="1">
+        <a:defRPr sz="1801" kern="1200">
           <a:solidFill>
             <a:schemeClr val="tx1"/>
           </a:solidFill>
@@ -3403,7 +3430,7 @@
         </p:blipFill>
         <p:spPr>
           <a:xfrm>
-            <a:off x="0" y="597598"/>
+            <a:off x="0" y="597600"/>
             <a:ext cx="12192000" cy="5662804"/>
           </a:xfrm>
           <a:prstGeom prst="rect">
@@ -3425,8 +3452,8 @@
         </p:nvGrpSpPr>
         <p:grpSpPr>
           <a:xfrm>
-            <a:off x="9343598" y="671280"/>
-            <a:ext cx="1381318" cy="614816"/>
+            <a:off x="9343599" y="671281"/>
+            <a:ext cx="1381317" cy="614816"/>
             <a:chOff x="5405341" y="3052342"/>
             <a:chExt cx="1381318" cy="614816"/>
           </a:xfrm>
@@ -3513,6 +3540,1083 @@
 </p:sld>
 </file>
 
+<file path=ppt/slides/slide10.xml><?xml version="1.0" encoding="utf-8"?>
+<p:sld xmlns:a="http://schemas.openxmlformats.org/drawingml/2006/main" xmlns:r="http://schemas.openxmlformats.org/officeDocument/2006/relationships" xmlns:p="http://schemas.openxmlformats.org/presentationml/2006/main">
+  <p:cSld>
+    <p:spTree>
+      <p:nvGrpSpPr>
+        <p:cNvPr id="1" name=""/>
+        <p:cNvGrpSpPr/>
+        <p:nvPr/>
+      </p:nvGrpSpPr>
+      <p:grpSpPr>
+        <a:xfrm>
+          <a:off x="0" y="0"/>
+          <a:ext cx="0" cy="0"/>
+          <a:chOff x="0" y="0"/>
+          <a:chExt cx="0" cy="0"/>
+        </a:xfrm>
+      </p:grpSpPr>
+      <p:pic>
+        <p:nvPicPr>
+          <p:cNvPr id="5" name="Imagen 4">
+            <a:extLst>
+              <a:ext uri="{FF2B5EF4-FFF2-40B4-BE49-F238E27FC236}">
+                <a16:creationId xmlns:a16="http://schemas.microsoft.com/office/drawing/2014/main" id="{F928B963-E479-4613-8915-7EACE497D921}"/>
+              </a:ext>
+            </a:extLst>
+          </p:cNvPr>
+          <p:cNvPicPr>
+            <a:picLocks noChangeAspect="1"/>
+          </p:cNvPicPr>
+          <p:nvPr/>
+        </p:nvPicPr>
+        <p:blipFill>
+          <a:blip r:embed="rId2"/>
+          <a:stretch>
+            <a:fillRect/>
+          </a:stretch>
+        </p:blipFill>
+        <p:spPr>
+          <a:xfrm>
+            <a:off x="-3045" y="610995"/>
+            <a:ext cx="12192000" cy="5636009"/>
+          </a:xfrm>
+          <a:prstGeom prst="rect">
+            <a:avLst/>
+          </a:prstGeom>
+        </p:spPr>
+      </p:pic>
+      <p:sp>
+        <p:nvSpPr>
+          <p:cNvPr id="10" name="Rectángulo: esquinas redondeadas 9">
+            <a:extLst>
+              <a:ext uri="{FF2B5EF4-FFF2-40B4-BE49-F238E27FC236}">
+                <a16:creationId xmlns:a16="http://schemas.microsoft.com/office/drawing/2014/main" id="{ECA34B99-BF91-4FA3-BC80-88323CB940B0}"/>
+              </a:ext>
+            </a:extLst>
+          </p:cNvPr>
+          <p:cNvSpPr/>
+          <p:nvPr/>
+        </p:nvSpPr>
+        <p:spPr>
+          <a:xfrm>
+            <a:off x="11043576" y="757682"/>
+            <a:ext cx="1145381" cy="507831"/>
+          </a:xfrm>
+          <a:prstGeom prst="roundRect">
+            <a:avLst/>
+          </a:prstGeom>
+          <a:noFill/>
+          <a:ln>
+            <a:solidFill>
+              <a:srgbClr val="FF0000"/>
+            </a:solidFill>
+          </a:ln>
+        </p:spPr>
+        <p:style>
+          <a:lnRef idx="2">
+            <a:schemeClr val="accent1">
+              <a:shade val="50000"/>
+            </a:schemeClr>
+          </a:lnRef>
+          <a:fillRef idx="1">
+            <a:schemeClr val="accent1"/>
+          </a:fillRef>
+          <a:effectRef idx="0">
+            <a:schemeClr val="accent1"/>
+          </a:effectRef>
+          <a:fontRef idx="minor">
+            <a:schemeClr val="lt1"/>
+          </a:fontRef>
+        </p:style>
+        <p:txBody>
+          <a:bodyPr rtlCol="0" anchor="ctr"/>
+          <a:lstStyle/>
+          <a:p>
+            <a:pPr algn="ctr"/>
+            <a:endParaRPr lang="es-PE" sz="1801"/>
+          </a:p>
+        </p:txBody>
+      </p:sp>
+      <p:sp>
+        <p:nvSpPr>
+          <p:cNvPr id="11" name="CuadroTexto 10">
+            <a:extLst>
+              <a:ext uri="{FF2B5EF4-FFF2-40B4-BE49-F238E27FC236}">
+                <a16:creationId xmlns:a16="http://schemas.microsoft.com/office/drawing/2014/main" id="{C10DBC10-B7E4-4E18-BD55-FBA9AEFEB519}"/>
+              </a:ext>
+            </a:extLst>
+          </p:cNvPr>
+          <p:cNvSpPr txBox="1"/>
+          <p:nvPr/>
+        </p:nvSpPr>
+        <p:spPr>
+          <a:xfrm>
+            <a:off x="7103844" y="103166"/>
+            <a:ext cx="2909168" cy="369332"/>
+          </a:xfrm>
+          <a:prstGeom prst="rect">
+            <a:avLst/>
+          </a:prstGeom>
+          <a:noFill/>
+        </p:spPr>
+        <p:txBody>
+          <a:bodyPr wrap="square" rtlCol="0">
+            <a:spAutoFit/>
+          </a:bodyPr>
+          <a:lstStyle/>
+          <a:p>
+            <a:r>
+              <a:rPr lang="es-PE" sz="900" b="1" dirty="0">
+                <a:solidFill>
+                  <a:srgbClr val="FF0000"/>
+                </a:solidFill>
+              </a:rPr>
+              <a:t>Quitar este botón (imprimir)  y ajustar al espacio los botones de recarga datos y exportar Excel </a:t>
+            </a:r>
+          </a:p>
+        </p:txBody>
+      </p:sp>
+      <p:cxnSp>
+        <p:nvCxnSpPr>
+          <p:cNvPr id="12" name="Conector recto de flecha 11">
+            <a:extLst>
+              <a:ext uri="{FF2B5EF4-FFF2-40B4-BE49-F238E27FC236}">
+                <a16:creationId xmlns:a16="http://schemas.microsoft.com/office/drawing/2014/main" id="{455C0302-5F13-4749-AF65-1A3B9CE168D8}"/>
+              </a:ext>
+            </a:extLst>
+          </p:cNvPr>
+          <p:cNvCxnSpPr>
+            <a:cxnSpLocks/>
+          </p:cNvCxnSpPr>
+          <p:nvPr/>
+        </p:nvCxnSpPr>
+        <p:spPr>
+          <a:xfrm>
+            <a:off x="10013012" y="255181"/>
+            <a:ext cx="1371600" cy="502500"/>
+          </a:xfrm>
+          <a:prstGeom prst="straightConnector1">
+            <a:avLst/>
+          </a:prstGeom>
+          <a:ln>
+            <a:solidFill>
+              <a:srgbClr val="FF0000"/>
+            </a:solidFill>
+            <a:tailEnd type="triangle"/>
+          </a:ln>
+        </p:spPr>
+        <p:style>
+          <a:lnRef idx="1">
+            <a:schemeClr val="accent1"/>
+          </a:lnRef>
+          <a:fillRef idx="0">
+            <a:schemeClr val="accent1"/>
+          </a:fillRef>
+          <a:effectRef idx="0">
+            <a:schemeClr val="accent1"/>
+          </a:effectRef>
+          <a:fontRef idx="minor">
+            <a:schemeClr val="tx1"/>
+          </a:fontRef>
+        </p:style>
+      </p:cxnSp>
+    </p:spTree>
+    <p:extLst>
+      <p:ext uri="{BB962C8B-B14F-4D97-AF65-F5344CB8AC3E}">
+        <p14:creationId xmlns:p14="http://schemas.microsoft.com/office/powerpoint/2010/main" val="474947224"/>
+      </p:ext>
+    </p:extLst>
+  </p:cSld>
+  <p:clrMapOvr>
+    <a:masterClrMapping/>
+  </p:clrMapOvr>
+</p:sld>
+</file>
+
+<file path=ppt/slides/slide11.xml><?xml version="1.0" encoding="utf-8"?>
+<p:sld xmlns:a="http://schemas.openxmlformats.org/drawingml/2006/main" xmlns:r="http://schemas.openxmlformats.org/officeDocument/2006/relationships" xmlns:p="http://schemas.openxmlformats.org/presentationml/2006/main">
+  <p:cSld>
+    <p:spTree>
+      <p:nvGrpSpPr>
+        <p:cNvPr id="1" name=""/>
+        <p:cNvGrpSpPr/>
+        <p:nvPr/>
+      </p:nvGrpSpPr>
+      <p:grpSpPr>
+        <a:xfrm>
+          <a:off x="0" y="0"/>
+          <a:ext cx="0" cy="0"/>
+          <a:chOff x="0" y="0"/>
+          <a:chExt cx="0" cy="0"/>
+        </a:xfrm>
+      </p:grpSpPr>
+      <p:pic>
+        <p:nvPicPr>
+          <p:cNvPr id="5" name="Imagen 4">
+            <a:extLst>
+              <a:ext uri="{FF2B5EF4-FFF2-40B4-BE49-F238E27FC236}">
+                <a16:creationId xmlns:a16="http://schemas.microsoft.com/office/drawing/2014/main" id="{48F6DD2F-C0FD-4EA7-87D9-0E69F0BED889}"/>
+              </a:ext>
+            </a:extLst>
+          </p:cNvPr>
+          <p:cNvPicPr>
+            <a:picLocks noChangeAspect="1"/>
+          </p:cNvPicPr>
+          <p:nvPr/>
+        </p:nvPicPr>
+        <p:blipFill>
+          <a:blip r:embed="rId2"/>
+          <a:stretch>
+            <a:fillRect/>
+          </a:stretch>
+        </p:blipFill>
+        <p:spPr>
+          <a:xfrm>
+            <a:off x="0" y="591361"/>
+            <a:ext cx="12192000" cy="5675278"/>
+          </a:xfrm>
+          <a:prstGeom prst="rect">
+            <a:avLst/>
+          </a:prstGeom>
+        </p:spPr>
+      </p:pic>
+      <p:sp>
+        <p:nvSpPr>
+          <p:cNvPr id="6" name="Rectángulo: esquinas redondeadas 5">
+            <a:extLst>
+              <a:ext uri="{FF2B5EF4-FFF2-40B4-BE49-F238E27FC236}">
+                <a16:creationId xmlns:a16="http://schemas.microsoft.com/office/drawing/2014/main" id="{22302BF1-0AB5-4985-9302-9C5051CDE503}"/>
+              </a:ext>
+            </a:extLst>
+          </p:cNvPr>
+          <p:cNvSpPr/>
+          <p:nvPr/>
+        </p:nvSpPr>
+        <p:spPr>
+          <a:xfrm>
+            <a:off x="8853308" y="2067867"/>
+            <a:ext cx="3338692" cy="2504133"/>
+          </a:xfrm>
+          <a:prstGeom prst="roundRect">
+            <a:avLst/>
+          </a:prstGeom>
+          <a:noFill/>
+          <a:ln>
+            <a:solidFill>
+              <a:srgbClr val="FF0000"/>
+            </a:solidFill>
+          </a:ln>
+        </p:spPr>
+        <p:style>
+          <a:lnRef idx="2">
+            <a:schemeClr val="accent1">
+              <a:shade val="50000"/>
+            </a:schemeClr>
+          </a:lnRef>
+          <a:fillRef idx="1">
+            <a:schemeClr val="accent1"/>
+          </a:fillRef>
+          <a:effectRef idx="0">
+            <a:schemeClr val="accent1"/>
+          </a:effectRef>
+          <a:fontRef idx="minor">
+            <a:schemeClr val="lt1"/>
+          </a:fontRef>
+        </p:style>
+        <p:txBody>
+          <a:bodyPr rtlCol="0" anchor="ctr"/>
+          <a:lstStyle/>
+          <a:p>
+            <a:pPr algn="ctr"/>
+            <a:endParaRPr lang="es-PE" sz="1801"/>
+          </a:p>
+        </p:txBody>
+      </p:sp>
+      <p:sp>
+        <p:nvSpPr>
+          <p:cNvPr id="7" name="CuadroTexto 6">
+            <a:extLst>
+              <a:ext uri="{FF2B5EF4-FFF2-40B4-BE49-F238E27FC236}">
+                <a16:creationId xmlns:a16="http://schemas.microsoft.com/office/drawing/2014/main" id="{A936A749-20C0-4D78-90EF-407560A4BADE}"/>
+              </a:ext>
+            </a:extLst>
+          </p:cNvPr>
+          <p:cNvSpPr txBox="1"/>
+          <p:nvPr/>
+        </p:nvSpPr>
+        <p:spPr>
+          <a:xfrm>
+            <a:off x="5388671" y="4960542"/>
+            <a:ext cx="2909168" cy="230832"/>
+          </a:xfrm>
+          <a:prstGeom prst="rect">
+            <a:avLst/>
+          </a:prstGeom>
+          <a:noFill/>
+          <a:ln>
+            <a:solidFill>
+              <a:srgbClr val="C00000"/>
+            </a:solidFill>
+          </a:ln>
+        </p:spPr>
+        <p:txBody>
+          <a:bodyPr wrap="square" rtlCol="0">
+            <a:spAutoFit/>
+          </a:bodyPr>
+          <a:lstStyle/>
+          <a:p>
+            <a:r>
+              <a:rPr lang="es-PE" sz="900" b="1" dirty="0">
+                <a:solidFill>
+                  <a:srgbClr val="FF0000"/>
+                </a:solidFill>
+              </a:rPr>
+              <a:t>Esta sección tenga información real y actualizada, </a:t>
+            </a:r>
+          </a:p>
+        </p:txBody>
+      </p:sp>
+      <p:cxnSp>
+        <p:nvCxnSpPr>
+          <p:cNvPr id="8" name="Conector recto de flecha 7">
+            <a:extLst>
+              <a:ext uri="{FF2B5EF4-FFF2-40B4-BE49-F238E27FC236}">
+                <a16:creationId xmlns:a16="http://schemas.microsoft.com/office/drawing/2014/main" id="{2A7E93F5-4625-42E8-8F18-5AE0B37FA7BF}"/>
+              </a:ext>
+            </a:extLst>
+          </p:cNvPr>
+          <p:cNvCxnSpPr>
+            <a:cxnSpLocks/>
+          </p:cNvCxnSpPr>
+          <p:nvPr/>
+        </p:nvCxnSpPr>
+        <p:spPr>
+          <a:xfrm flipV="1">
+            <a:off x="8297840" y="4572001"/>
+            <a:ext cx="2224814" cy="573205"/>
+          </a:xfrm>
+          <a:prstGeom prst="straightConnector1">
+            <a:avLst/>
+          </a:prstGeom>
+          <a:ln>
+            <a:solidFill>
+              <a:srgbClr val="FF0000"/>
+            </a:solidFill>
+            <a:tailEnd type="triangle"/>
+          </a:ln>
+        </p:spPr>
+        <p:style>
+          <a:lnRef idx="1">
+            <a:schemeClr val="accent1"/>
+          </a:lnRef>
+          <a:fillRef idx="0">
+            <a:schemeClr val="accent1"/>
+          </a:fillRef>
+          <a:effectRef idx="0">
+            <a:schemeClr val="accent1"/>
+          </a:effectRef>
+          <a:fontRef idx="minor">
+            <a:schemeClr val="tx1"/>
+          </a:fontRef>
+        </p:style>
+      </p:cxnSp>
+    </p:spTree>
+    <p:extLst>
+      <p:ext uri="{BB962C8B-B14F-4D97-AF65-F5344CB8AC3E}">
+        <p14:creationId xmlns:p14="http://schemas.microsoft.com/office/powerpoint/2010/main" val="607488743"/>
+      </p:ext>
+    </p:extLst>
+  </p:cSld>
+  <p:clrMapOvr>
+    <a:masterClrMapping/>
+  </p:clrMapOvr>
+</p:sld>
+</file>
+
+<file path=ppt/slides/slide12.xml><?xml version="1.0" encoding="utf-8"?>
+<p:sld xmlns:a="http://schemas.openxmlformats.org/drawingml/2006/main" xmlns:r="http://schemas.openxmlformats.org/officeDocument/2006/relationships" xmlns:p="http://schemas.openxmlformats.org/presentationml/2006/main">
+  <p:cSld>
+    <p:spTree>
+      <p:nvGrpSpPr>
+        <p:cNvPr id="1" name=""/>
+        <p:cNvGrpSpPr/>
+        <p:nvPr/>
+      </p:nvGrpSpPr>
+      <p:grpSpPr>
+        <a:xfrm>
+          <a:off x="0" y="0"/>
+          <a:ext cx="0" cy="0"/>
+          <a:chOff x="0" y="0"/>
+          <a:chExt cx="0" cy="0"/>
+        </a:xfrm>
+      </p:grpSpPr>
+      <p:pic>
+        <p:nvPicPr>
+          <p:cNvPr id="5" name="Imagen 4">
+            <a:extLst>
+              <a:ext uri="{FF2B5EF4-FFF2-40B4-BE49-F238E27FC236}">
+                <a16:creationId xmlns:a16="http://schemas.microsoft.com/office/drawing/2014/main" id="{AF2B5438-EBFA-4951-8BF5-22933488727E}"/>
+              </a:ext>
+            </a:extLst>
+          </p:cNvPr>
+          <p:cNvPicPr>
+            <a:picLocks noChangeAspect="1"/>
+          </p:cNvPicPr>
+          <p:nvPr/>
+        </p:nvPicPr>
+        <p:blipFill>
+          <a:blip r:embed="rId2"/>
+          <a:stretch>
+            <a:fillRect/>
+          </a:stretch>
+        </p:blipFill>
+        <p:spPr>
+          <a:xfrm>
+            <a:off x="1237965" y="566338"/>
+            <a:ext cx="4086795" cy="5725324"/>
+          </a:xfrm>
+          <a:prstGeom prst="rect">
+            <a:avLst/>
+          </a:prstGeom>
+        </p:spPr>
+      </p:pic>
+      <p:pic>
+        <p:nvPicPr>
+          <p:cNvPr id="6" name="Imagen 5">
+            <a:extLst>
+              <a:ext uri="{FF2B5EF4-FFF2-40B4-BE49-F238E27FC236}">
+                <a16:creationId xmlns:a16="http://schemas.microsoft.com/office/drawing/2014/main" id="{8325AE9D-A688-4995-9922-CD947C046851}"/>
+              </a:ext>
+            </a:extLst>
+          </p:cNvPr>
+          <p:cNvPicPr>
+            <a:picLocks noChangeAspect="1"/>
+          </p:cNvPicPr>
+          <p:nvPr/>
+        </p:nvPicPr>
+        <p:blipFill>
+          <a:blip r:embed="rId2"/>
+          <a:stretch>
+            <a:fillRect/>
+          </a:stretch>
+        </p:blipFill>
+        <p:spPr>
+          <a:xfrm>
+            <a:off x="6362415" y="566338"/>
+            <a:ext cx="4086795" cy="5725324"/>
+          </a:xfrm>
+          <a:prstGeom prst="rect">
+            <a:avLst/>
+          </a:prstGeom>
+        </p:spPr>
+      </p:pic>
+      <p:sp>
+        <p:nvSpPr>
+          <p:cNvPr id="9" name="Rectángulo 8">
+            <a:extLst>
+              <a:ext uri="{FF2B5EF4-FFF2-40B4-BE49-F238E27FC236}">
+                <a16:creationId xmlns:a16="http://schemas.microsoft.com/office/drawing/2014/main" id="{24B73959-441F-41D2-910F-508B780D09EF}"/>
+              </a:ext>
+            </a:extLst>
+          </p:cNvPr>
+          <p:cNvSpPr/>
+          <p:nvPr/>
+        </p:nvSpPr>
+        <p:spPr>
+          <a:xfrm>
+            <a:off x="6523630" y="1064525"/>
+            <a:ext cx="3780430" cy="4312693"/>
+          </a:xfrm>
+          <a:prstGeom prst="rect">
+            <a:avLst/>
+          </a:prstGeom>
+          <a:solidFill>
+            <a:schemeClr val="bg1"/>
+          </a:solidFill>
+          <a:ln>
+            <a:noFill/>
+          </a:ln>
+        </p:spPr>
+        <p:style>
+          <a:lnRef idx="2">
+            <a:schemeClr val="accent1">
+              <a:shade val="50000"/>
+            </a:schemeClr>
+          </a:lnRef>
+          <a:fillRef idx="1">
+            <a:schemeClr val="accent1"/>
+          </a:fillRef>
+          <a:effectRef idx="0">
+            <a:schemeClr val="accent1"/>
+          </a:effectRef>
+          <a:fontRef idx="minor">
+            <a:schemeClr val="lt1"/>
+          </a:fontRef>
+        </p:style>
+        <p:txBody>
+          <a:bodyPr rtlCol="0" anchor="ctr"/>
+          <a:lstStyle/>
+          <a:p>
+            <a:pPr algn="ctr"/>
+            <a:endParaRPr lang="es-PE"/>
+          </a:p>
+        </p:txBody>
+      </p:sp>
+      <p:pic>
+        <p:nvPicPr>
+          <p:cNvPr id="11" name="Imagen 10">
+            <a:extLst>
+              <a:ext uri="{FF2B5EF4-FFF2-40B4-BE49-F238E27FC236}">
+                <a16:creationId xmlns:a16="http://schemas.microsoft.com/office/drawing/2014/main" id="{9BC60088-E63A-4F0A-B2F6-C59C032ED2CC}"/>
+              </a:ext>
+            </a:extLst>
+          </p:cNvPr>
+          <p:cNvPicPr>
+            <a:picLocks noChangeAspect="1"/>
+          </p:cNvPicPr>
+          <p:nvPr/>
+        </p:nvPicPr>
+        <p:blipFill>
+          <a:blip r:embed="rId3"/>
+          <a:stretch>
+            <a:fillRect/>
+          </a:stretch>
+        </p:blipFill>
+        <p:spPr>
+          <a:xfrm>
+            <a:off x="6515009" y="1828799"/>
+            <a:ext cx="3715784" cy="3702122"/>
+          </a:xfrm>
+          <a:prstGeom prst="rect">
+            <a:avLst/>
+          </a:prstGeom>
+        </p:spPr>
+      </p:pic>
+      <p:sp>
+        <p:nvSpPr>
+          <p:cNvPr id="12" name="CuadroTexto 11">
+            <a:extLst>
+              <a:ext uri="{FF2B5EF4-FFF2-40B4-BE49-F238E27FC236}">
+                <a16:creationId xmlns:a16="http://schemas.microsoft.com/office/drawing/2014/main" id="{B1D37B48-A579-403A-B7E7-5BBC30E1E5E2}"/>
+              </a:ext>
+            </a:extLst>
+          </p:cNvPr>
+          <p:cNvSpPr txBox="1"/>
+          <p:nvPr/>
+        </p:nvSpPr>
+        <p:spPr>
+          <a:xfrm>
+            <a:off x="1826778" y="208068"/>
+            <a:ext cx="2909168" cy="230832"/>
+          </a:xfrm>
+          <a:prstGeom prst="rect">
+            <a:avLst/>
+          </a:prstGeom>
+          <a:noFill/>
+          <a:ln>
+            <a:solidFill>
+              <a:srgbClr val="C00000"/>
+            </a:solidFill>
+          </a:ln>
+        </p:spPr>
+        <p:txBody>
+          <a:bodyPr wrap="square" rtlCol="0">
+            <a:spAutoFit/>
+          </a:bodyPr>
+          <a:lstStyle/>
+          <a:p>
+            <a:pPr algn="ctr"/>
+            <a:r>
+              <a:rPr lang="es-PE" sz="900" b="1" dirty="0">
+                <a:solidFill>
+                  <a:srgbClr val="FF0000"/>
+                </a:solidFill>
+              </a:rPr>
+              <a:t>ASÍ SE VE ACTUALMENTE</a:t>
+            </a:r>
+          </a:p>
+        </p:txBody>
+      </p:sp>
+      <p:sp>
+        <p:nvSpPr>
+          <p:cNvPr id="13" name="CuadroTexto 12">
+            <a:extLst>
+              <a:ext uri="{FF2B5EF4-FFF2-40B4-BE49-F238E27FC236}">
+                <a16:creationId xmlns:a16="http://schemas.microsoft.com/office/drawing/2014/main" id="{86B6F0F5-4C07-40BE-B719-DD4E1E34CD89}"/>
+              </a:ext>
+            </a:extLst>
+          </p:cNvPr>
+          <p:cNvSpPr txBox="1"/>
+          <p:nvPr/>
+        </p:nvSpPr>
+        <p:spPr>
+          <a:xfrm>
+            <a:off x="6918317" y="181803"/>
+            <a:ext cx="2909168" cy="230832"/>
+          </a:xfrm>
+          <a:prstGeom prst="rect">
+            <a:avLst/>
+          </a:prstGeom>
+          <a:noFill/>
+          <a:ln>
+            <a:solidFill>
+              <a:srgbClr val="C00000"/>
+            </a:solidFill>
+          </a:ln>
+        </p:spPr>
+        <p:txBody>
+          <a:bodyPr wrap="square" rtlCol="0">
+            <a:spAutoFit/>
+          </a:bodyPr>
+          <a:lstStyle/>
+          <a:p>
+            <a:pPr algn="ctr"/>
+            <a:r>
+              <a:rPr lang="es-PE" sz="900" b="1" dirty="0">
+                <a:solidFill>
+                  <a:srgbClr val="FF0000"/>
+                </a:solidFill>
+              </a:rPr>
+              <a:t>QUIERO QUE SE VEA ASI</a:t>
+            </a:r>
+          </a:p>
+        </p:txBody>
+      </p:sp>
+    </p:spTree>
+    <p:extLst>
+      <p:ext uri="{BB962C8B-B14F-4D97-AF65-F5344CB8AC3E}">
+        <p14:creationId xmlns:p14="http://schemas.microsoft.com/office/powerpoint/2010/main" val="204669707"/>
+      </p:ext>
+    </p:extLst>
+  </p:cSld>
+  <p:clrMapOvr>
+    <a:masterClrMapping/>
+  </p:clrMapOvr>
+</p:sld>
+</file>
+
+<file path=ppt/slides/slide13.xml><?xml version="1.0" encoding="utf-8"?>
+<p:sld xmlns:a="http://schemas.openxmlformats.org/drawingml/2006/main" xmlns:r="http://schemas.openxmlformats.org/officeDocument/2006/relationships" xmlns:p="http://schemas.openxmlformats.org/presentationml/2006/main">
+  <p:cSld>
+    <p:spTree>
+      <p:nvGrpSpPr>
+        <p:cNvPr id="1" name=""/>
+        <p:cNvGrpSpPr/>
+        <p:nvPr/>
+      </p:nvGrpSpPr>
+      <p:grpSpPr>
+        <a:xfrm>
+          <a:off x="0" y="0"/>
+          <a:ext cx="0" cy="0"/>
+          <a:chOff x="0" y="0"/>
+          <a:chExt cx="0" cy="0"/>
+        </a:xfrm>
+      </p:grpSpPr>
+      <p:pic>
+        <p:nvPicPr>
+          <p:cNvPr id="5" name="Imagen 4">
+            <a:extLst>
+              <a:ext uri="{FF2B5EF4-FFF2-40B4-BE49-F238E27FC236}">
+                <a16:creationId xmlns:a16="http://schemas.microsoft.com/office/drawing/2014/main" id="{570D2FC6-0E81-4AEB-B537-50272B81AA42}"/>
+              </a:ext>
+            </a:extLst>
+          </p:cNvPr>
+          <p:cNvPicPr>
+            <a:picLocks noChangeAspect="1"/>
+          </p:cNvPicPr>
+          <p:nvPr/>
+        </p:nvPicPr>
+        <p:blipFill>
+          <a:blip r:embed="rId2"/>
+          <a:stretch>
+            <a:fillRect/>
+          </a:stretch>
+        </p:blipFill>
+        <p:spPr>
+          <a:xfrm>
+            <a:off x="161318" y="152014"/>
+            <a:ext cx="8697539" cy="5525271"/>
+          </a:xfrm>
+          <a:prstGeom prst="rect">
+            <a:avLst/>
+          </a:prstGeom>
+        </p:spPr>
+      </p:pic>
+      <p:pic>
+        <p:nvPicPr>
+          <p:cNvPr id="7" name="Imagen 6">
+            <a:extLst>
+              <a:ext uri="{FF2B5EF4-FFF2-40B4-BE49-F238E27FC236}">
+                <a16:creationId xmlns:a16="http://schemas.microsoft.com/office/drawing/2014/main" id="{A5326FFA-412C-4F02-BA79-B511355D6ADD}"/>
+              </a:ext>
+            </a:extLst>
+          </p:cNvPr>
+          <p:cNvPicPr>
+            <a:picLocks noChangeAspect="1"/>
+          </p:cNvPicPr>
+          <p:nvPr/>
+        </p:nvPicPr>
+        <p:blipFill>
+          <a:blip r:embed="rId3"/>
+          <a:stretch>
+            <a:fillRect/>
+          </a:stretch>
+        </p:blipFill>
+        <p:spPr>
+          <a:xfrm>
+            <a:off x="7985651" y="47224"/>
+            <a:ext cx="10069330" cy="5734850"/>
+          </a:xfrm>
+          <a:prstGeom prst="rect">
+            <a:avLst/>
+          </a:prstGeom>
+        </p:spPr>
+      </p:pic>
+      <p:pic>
+        <p:nvPicPr>
+          <p:cNvPr id="9" name="Imagen 8">
+            <a:extLst>
+              <a:ext uri="{FF2B5EF4-FFF2-40B4-BE49-F238E27FC236}">
+                <a16:creationId xmlns:a16="http://schemas.microsoft.com/office/drawing/2014/main" id="{EA52AAA2-BCBB-4F28-B7FF-39EDF4F65EEA}"/>
+              </a:ext>
+            </a:extLst>
+          </p:cNvPr>
+          <p:cNvPicPr>
+            <a:picLocks noChangeAspect="1"/>
+          </p:cNvPicPr>
+          <p:nvPr/>
+        </p:nvPicPr>
+        <p:blipFill>
+          <a:blip r:embed="rId4"/>
+          <a:stretch>
+            <a:fillRect/>
+          </a:stretch>
+        </p:blipFill>
+        <p:spPr>
+          <a:xfrm>
+            <a:off x="-869189" y="265047"/>
+            <a:ext cx="12192000" cy="5640141"/>
+          </a:xfrm>
+          <a:prstGeom prst="rect">
+            <a:avLst/>
+          </a:prstGeom>
+        </p:spPr>
+      </p:pic>
+      <p:pic>
+        <p:nvPicPr>
+          <p:cNvPr id="11" name="Imagen 10">
+            <a:extLst>
+              <a:ext uri="{FF2B5EF4-FFF2-40B4-BE49-F238E27FC236}">
+                <a16:creationId xmlns:a16="http://schemas.microsoft.com/office/drawing/2014/main" id="{B32A1092-AF1D-4AAA-A52B-CA139726B993}"/>
+              </a:ext>
+            </a:extLst>
+          </p:cNvPr>
+          <p:cNvPicPr>
+            <a:picLocks noChangeAspect="1"/>
+          </p:cNvPicPr>
+          <p:nvPr/>
+        </p:nvPicPr>
+        <p:blipFill>
+          <a:blip r:embed="rId5"/>
+          <a:stretch>
+            <a:fillRect/>
+          </a:stretch>
+        </p:blipFill>
+        <p:spPr>
+          <a:xfrm>
+            <a:off x="5226811" y="1169752"/>
+            <a:ext cx="12192000" cy="5679448"/>
+          </a:xfrm>
+          <a:prstGeom prst="rect">
+            <a:avLst/>
+          </a:prstGeom>
+        </p:spPr>
+      </p:pic>
+      <p:pic>
+        <p:nvPicPr>
+          <p:cNvPr id="13" name="Imagen 12">
+            <a:extLst>
+              <a:ext uri="{FF2B5EF4-FFF2-40B4-BE49-F238E27FC236}">
+                <a16:creationId xmlns:a16="http://schemas.microsoft.com/office/drawing/2014/main" id="{8268E78F-9D1E-4898-94EE-923B8635FCD0}"/>
+              </a:ext>
+            </a:extLst>
+          </p:cNvPr>
+          <p:cNvPicPr>
+            <a:picLocks noChangeAspect="1"/>
+          </p:cNvPicPr>
+          <p:nvPr/>
+        </p:nvPicPr>
+        <p:blipFill>
+          <a:blip r:embed="rId6"/>
+          <a:stretch>
+            <a:fillRect/>
+          </a:stretch>
+        </p:blipFill>
+        <p:spPr>
+          <a:xfrm>
+            <a:off x="0" y="1236000"/>
+            <a:ext cx="12192000" cy="5662804"/>
+          </a:xfrm>
+          <a:prstGeom prst="rect">
+            <a:avLst/>
+          </a:prstGeom>
+        </p:spPr>
+      </p:pic>
+    </p:spTree>
+    <p:extLst>
+      <p:ext uri="{BB962C8B-B14F-4D97-AF65-F5344CB8AC3E}">
+        <p14:creationId xmlns:p14="http://schemas.microsoft.com/office/powerpoint/2010/main" val="3981397942"/>
+      </p:ext>
+    </p:extLst>
+  </p:cSld>
+  <p:clrMapOvr>
+    <a:masterClrMapping/>
+  </p:clrMapOvr>
+</p:sld>
+</file>
+
+<file path=ppt/slides/slide14.xml><?xml version="1.0" encoding="utf-8"?>
+<p:sld xmlns:a="http://schemas.openxmlformats.org/drawingml/2006/main" xmlns:r="http://schemas.openxmlformats.org/officeDocument/2006/relationships" xmlns:p="http://schemas.openxmlformats.org/presentationml/2006/main">
+  <p:cSld>
+    <p:spTree>
+      <p:nvGrpSpPr>
+        <p:cNvPr id="1" name=""/>
+        <p:cNvGrpSpPr/>
+        <p:nvPr/>
+      </p:nvGrpSpPr>
+      <p:grpSpPr>
+        <a:xfrm>
+          <a:off x="0" y="0"/>
+          <a:ext cx="0" cy="0"/>
+          <a:chOff x="0" y="0"/>
+          <a:chExt cx="0" cy="0"/>
+        </a:xfrm>
+      </p:grpSpPr>
+      <p:pic>
+        <p:nvPicPr>
+          <p:cNvPr id="5" name="Imagen 4">
+            <a:extLst>
+              <a:ext uri="{FF2B5EF4-FFF2-40B4-BE49-F238E27FC236}">
+                <a16:creationId xmlns:a16="http://schemas.microsoft.com/office/drawing/2014/main" id="{F6609826-E3F1-4CC7-9B9E-B6FA37B25121}"/>
+              </a:ext>
+            </a:extLst>
+          </p:cNvPr>
+          <p:cNvPicPr>
+            <a:picLocks noChangeAspect="1"/>
+          </p:cNvPicPr>
+          <p:nvPr/>
+        </p:nvPicPr>
+        <p:blipFill>
+          <a:blip r:embed="rId2"/>
+          <a:stretch>
+            <a:fillRect/>
+          </a:stretch>
+        </p:blipFill>
+        <p:spPr>
+          <a:xfrm>
+            <a:off x="-1785937" y="0"/>
+            <a:ext cx="12192000" cy="5649079"/>
+          </a:xfrm>
+          <a:prstGeom prst="rect">
+            <a:avLst/>
+          </a:prstGeom>
+        </p:spPr>
+      </p:pic>
+      <p:pic>
+        <p:nvPicPr>
+          <p:cNvPr id="7" name="Imagen 6">
+            <a:extLst>
+              <a:ext uri="{FF2B5EF4-FFF2-40B4-BE49-F238E27FC236}">
+                <a16:creationId xmlns:a16="http://schemas.microsoft.com/office/drawing/2014/main" id="{B350C993-891B-4BCD-99C8-8EE200ADE0CF}"/>
+              </a:ext>
+            </a:extLst>
+          </p:cNvPr>
+          <p:cNvPicPr>
+            <a:picLocks noChangeAspect="1"/>
+          </p:cNvPicPr>
+          <p:nvPr/>
+        </p:nvPicPr>
+        <p:blipFill>
+          <a:blip r:embed="rId3"/>
+          <a:stretch>
+            <a:fillRect/>
+          </a:stretch>
+        </p:blipFill>
+        <p:spPr>
+          <a:xfrm>
+            <a:off x="5104705" y="609206"/>
+            <a:ext cx="9955014" cy="5639587"/>
+          </a:xfrm>
+          <a:prstGeom prst="rect">
+            <a:avLst/>
+          </a:prstGeom>
+        </p:spPr>
+      </p:pic>
+      <p:pic>
+        <p:nvPicPr>
+          <p:cNvPr id="9" name="Imagen 8">
+            <a:extLst>
+              <a:ext uri="{FF2B5EF4-FFF2-40B4-BE49-F238E27FC236}">
+                <a16:creationId xmlns:a16="http://schemas.microsoft.com/office/drawing/2014/main" id="{496593B4-5E9A-4DEB-9D01-E8290D857DAC}"/>
+              </a:ext>
+            </a:extLst>
+          </p:cNvPr>
+          <p:cNvPicPr>
+            <a:picLocks noChangeAspect="1"/>
+          </p:cNvPicPr>
+          <p:nvPr/>
+        </p:nvPicPr>
+        <p:blipFill>
+          <a:blip r:embed="rId4"/>
+          <a:stretch>
+            <a:fillRect/>
+          </a:stretch>
+        </p:blipFill>
+        <p:spPr>
+          <a:xfrm>
+            <a:off x="-1785937" y="2071300"/>
+            <a:ext cx="8649907" cy="5544324"/>
+          </a:xfrm>
+          <a:prstGeom prst="rect">
+            <a:avLst/>
+          </a:prstGeom>
+        </p:spPr>
+      </p:pic>
+      <p:pic>
+        <p:nvPicPr>
+          <p:cNvPr id="11" name="Imagen 10">
+            <a:extLst>
+              <a:ext uri="{FF2B5EF4-FFF2-40B4-BE49-F238E27FC236}">
+                <a16:creationId xmlns:a16="http://schemas.microsoft.com/office/drawing/2014/main" id="{07B36C88-4B0A-4319-9A89-B3DA776510F7}"/>
+              </a:ext>
+            </a:extLst>
+          </p:cNvPr>
+          <p:cNvPicPr>
+            <a:picLocks noChangeAspect="1"/>
+          </p:cNvPicPr>
+          <p:nvPr/>
+        </p:nvPicPr>
+        <p:blipFill>
+          <a:blip r:embed="rId5"/>
+          <a:stretch>
+            <a:fillRect/>
+          </a:stretch>
+        </p:blipFill>
+        <p:spPr>
+          <a:xfrm>
+            <a:off x="4961876" y="1995090"/>
+            <a:ext cx="9297698" cy="5620534"/>
+          </a:xfrm>
+          <a:prstGeom prst="rect">
+            <a:avLst/>
+          </a:prstGeom>
+        </p:spPr>
+      </p:pic>
+      <p:pic>
+        <p:nvPicPr>
+          <p:cNvPr id="13" name="Imagen 12">
+            <a:extLst>
+              <a:ext uri="{FF2B5EF4-FFF2-40B4-BE49-F238E27FC236}">
+                <a16:creationId xmlns:a16="http://schemas.microsoft.com/office/drawing/2014/main" id="{04FCE9CE-ED09-4DDD-9F57-19F2EEF76D1B}"/>
+              </a:ext>
+            </a:extLst>
+          </p:cNvPr>
+          <p:cNvPicPr>
+            <a:picLocks noChangeAspect="1"/>
+          </p:cNvPicPr>
+          <p:nvPr/>
+        </p:nvPicPr>
+        <p:blipFill>
+          <a:blip r:embed="rId6"/>
+          <a:stretch>
+            <a:fillRect/>
+          </a:stretch>
+        </p:blipFill>
+        <p:spPr>
+          <a:xfrm>
+            <a:off x="8538889" y="0"/>
+            <a:ext cx="6277851" cy="2152950"/>
+          </a:xfrm>
+          <a:prstGeom prst="rect">
+            <a:avLst/>
+          </a:prstGeom>
+        </p:spPr>
+      </p:pic>
+      <p:pic>
+        <p:nvPicPr>
+          <p:cNvPr id="15" name="Imagen 14">
+            <a:extLst>
+              <a:ext uri="{FF2B5EF4-FFF2-40B4-BE49-F238E27FC236}">
+                <a16:creationId xmlns:a16="http://schemas.microsoft.com/office/drawing/2014/main" id="{99BBA6EB-5DA0-4358-B865-A3B07957101B}"/>
+              </a:ext>
+            </a:extLst>
+          </p:cNvPr>
+          <p:cNvPicPr>
+            <a:picLocks noChangeAspect="1"/>
+          </p:cNvPicPr>
+          <p:nvPr/>
+        </p:nvPicPr>
+        <p:blipFill>
+          <a:blip r:embed="rId7"/>
+          <a:stretch>
+            <a:fillRect/>
+          </a:stretch>
+        </p:blipFill>
+        <p:spPr>
+          <a:xfrm>
+            <a:off x="-2295788" y="3532047"/>
+            <a:ext cx="9259592" cy="5649113"/>
+          </a:xfrm>
+          <a:prstGeom prst="rect">
+            <a:avLst/>
+          </a:prstGeom>
+        </p:spPr>
+      </p:pic>
+      <p:pic>
+        <p:nvPicPr>
+          <p:cNvPr id="17" name="Imagen 16">
+            <a:extLst>
+              <a:ext uri="{FF2B5EF4-FFF2-40B4-BE49-F238E27FC236}">
+                <a16:creationId xmlns:a16="http://schemas.microsoft.com/office/drawing/2014/main" id="{7AF6947C-2A36-4F69-8427-32F9B10B74A6}"/>
+              </a:ext>
+            </a:extLst>
+          </p:cNvPr>
+          <p:cNvPicPr>
+            <a:picLocks noChangeAspect="1"/>
+          </p:cNvPicPr>
+          <p:nvPr/>
+        </p:nvPicPr>
+        <p:blipFill>
+          <a:blip r:embed="rId8"/>
+          <a:stretch>
+            <a:fillRect/>
+          </a:stretch>
+        </p:blipFill>
+        <p:spPr>
+          <a:xfrm>
+            <a:off x="3760838" y="4891370"/>
+            <a:ext cx="12192000" cy="5658018"/>
+          </a:xfrm>
+          <a:prstGeom prst="rect">
+            <a:avLst/>
+          </a:prstGeom>
+        </p:spPr>
+      </p:pic>
+    </p:spTree>
+    <p:extLst>
+      <p:ext uri="{BB962C8B-B14F-4D97-AF65-F5344CB8AC3E}">
+        <p14:creationId xmlns:p14="http://schemas.microsoft.com/office/powerpoint/2010/main" val="917896382"/>
+      </p:ext>
+    </p:extLst>
+  </p:cSld>
+  <p:clrMapOvr>
+    <a:masterClrMapping/>
+  </p:clrMapOvr>
+</p:sld>
+</file>
+
 <file path=ppt/slides/slide2.xml><?xml version="1.0" encoding="utf-8"?>
 <p:sld xmlns:a="http://schemas.openxmlformats.org/drawingml/2006/main" xmlns:r="http://schemas.openxmlformats.org/officeDocument/2006/relationships" xmlns:p="http://schemas.openxmlformats.org/presentationml/2006/main">
   <p:cSld>
@@ -3552,7 +4656,7 @@
         </p:blipFill>
         <p:spPr>
           <a:xfrm>
-            <a:off x="4752787" y="861654"/>
+            <a:off x="4752788" y="861654"/>
             <a:ext cx="2686425" cy="5134692"/>
           </a:xfrm>
           <a:prstGeom prst="rect">
@@ -3574,8 +4678,8 @@
         </p:nvSpPr>
         <p:spPr>
           <a:xfrm>
-            <a:off x="6518313" y="1035586"/>
-            <a:ext cx="697735" cy="227681"/>
+            <a:off x="6518313" y="1035587"/>
+            <a:ext cx="697735" cy="227682"/>
           </a:xfrm>
           <a:prstGeom prst="rect">
             <a:avLst/>
@@ -3608,7 +4712,7 @@
           <a:lstStyle/>
           <a:p>
             <a:pPr algn="ctr"/>
-            <a:endParaRPr lang="es-PE"/>
+            <a:endParaRPr lang="es-PE" sz="1801"/>
           </a:p>
         </p:txBody>
       </p:sp>
@@ -3626,10 +4730,10 @@
         </p:nvGrpSpPr>
         <p:grpSpPr>
           <a:xfrm>
-            <a:off x="6672515" y="1031464"/>
-            <a:ext cx="385625" cy="191408"/>
+            <a:off x="6672520" y="1031470"/>
+            <a:ext cx="418706" cy="191408"/>
             <a:chOff x="5669377" y="3052342"/>
-            <a:chExt cx="418705" cy="206548"/>
+            <a:chExt cx="454624" cy="206548"/>
           </a:xfrm>
         </p:grpSpPr>
         <p:pic>
@@ -3676,8 +4780,8 @@
           </p:nvSpPr>
           <p:spPr>
             <a:xfrm>
-              <a:off x="5669378" y="3052342"/>
-              <a:ext cx="418704" cy="138499"/>
+              <a:off x="5669379" y="3052342"/>
+              <a:ext cx="454622" cy="149454"/>
             </a:xfrm>
             <a:prstGeom prst="rect">
               <a:avLst/>
@@ -3745,8 +4849,8 @@
         </p:nvGrpSpPr>
         <p:grpSpPr>
           <a:xfrm>
-            <a:off x="5405341" y="3052342"/>
-            <a:ext cx="1381318" cy="614816"/>
+            <a:off x="5405343" y="3052342"/>
+            <a:ext cx="1381317" cy="614816"/>
             <a:chOff x="5405341" y="3052342"/>
             <a:chExt cx="1381318" cy="614816"/>
           </a:xfrm>
@@ -3872,7 +4976,7 @@
         </p:blipFill>
         <p:spPr>
           <a:xfrm>
-            <a:off x="2559360" y="263025"/>
+            <a:off x="2559361" y="263026"/>
             <a:ext cx="9636958" cy="6030167"/>
           </a:xfrm>
           <a:prstGeom prst="rect">
@@ -3932,7 +5036,7 @@
         </p:blipFill>
         <p:spPr>
           <a:xfrm>
-            <a:off x="2558348" y="289951"/>
+            <a:off x="2558349" y="289951"/>
             <a:ext cx="3010320" cy="514564"/>
           </a:xfrm>
           <a:prstGeom prst="rect">
@@ -3954,8 +5058,8 @@
         </p:nvSpPr>
         <p:spPr>
           <a:xfrm>
-            <a:off x="5617308" y="647439"/>
-            <a:ext cx="814647" cy="184666"/>
+            <a:off x="5617310" y="647439"/>
+            <a:ext cx="816249" cy="184794"/>
           </a:xfrm>
           <a:prstGeom prst="rect">
             <a:avLst/>
@@ -3969,7 +5073,7 @@
           <a:lstStyle/>
           <a:p>
             <a:r>
-              <a:rPr lang="es-PE" sz="600" b="1" dirty="0">
+              <a:rPr lang="es-PE" sz="601" b="1" dirty="0">
                 <a:latin typeface="Yu Gothic" panose="020B0400000000000000" pitchFamily="34" charset="-128"/>
                 <a:ea typeface="Yu Gothic" panose="020B0400000000000000" pitchFamily="34" charset="-128"/>
               </a:rPr>
@@ -4006,8 +5110,8 @@
         </p:blipFill>
         <p:spPr>
           <a:xfrm>
-            <a:off x="6383315" y="564808"/>
-            <a:ext cx="1090776" cy="208929"/>
+            <a:off x="6383314" y="564809"/>
+            <a:ext cx="1090777" cy="208930"/>
           </a:xfrm>
           <a:prstGeom prst="rect">
             <a:avLst/>
@@ -4036,7 +5140,7 @@
         </p:blipFill>
         <p:spPr>
           <a:xfrm>
-            <a:off x="2787480" y="804788"/>
+            <a:off x="2787482" y="804789"/>
             <a:ext cx="4893012" cy="390389"/>
           </a:xfrm>
           <a:prstGeom prst="rect">
@@ -4066,7 +5170,7 @@
         </p:blipFill>
         <p:spPr>
           <a:xfrm>
-            <a:off x="8357826" y="503737"/>
+            <a:off x="8357826" y="503738"/>
             <a:ext cx="1080000" cy="540000"/>
           </a:xfrm>
           <a:prstGeom prst="rect">
@@ -4126,7 +5230,7 @@
         </p:blipFill>
         <p:spPr>
           <a:xfrm>
-            <a:off x="10840225" y="520458"/>
+            <a:off x="10840226" y="520458"/>
             <a:ext cx="1080000" cy="540000"/>
           </a:xfrm>
           <a:prstGeom prst="rect">
@@ -4156,7 +5260,7 @@
         </p:blipFill>
         <p:spPr>
           <a:xfrm>
-            <a:off x="10062591" y="1202828"/>
+            <a:off x="10062590" y="1202828"/>
             <a:ext cx="1872000" cy="828000"/>
           </a:xfrm>
           <a:prstGeom prst="rect">
@@ -4246,7 +5350,7 @@
         </p:blipFill>
         <p:spPr>
           <a:xfrm>
-            <a:off x="2719240" y="1210463"/>
+            <a:off x="2719241" y="1210463"/>
             <a:ext cx="7308000" cy="482912"/>
           </a:xfrm>
           <a:prstGeom prst="rect">
@@ -4276,7 +5380,7 @@
         </p:blipFill>
         <p:spPr>
           <a:xfrm>
-            <a:off x="2705592" y="1735630"/>
+            <a:off x="2705593" y="1735632"/>
             <a:ext cx="7308000" cy="2899493"/>
           </a:xfrm>
           <a:prstGeom prst="rect">
@@ -4336,8 +5440,8 @@
         </p:blipFill>
         <p:spPr>
           <a:xfrm>
-            <a:off x="2705591" y="4652253"/>
-            <a:ext cx="3677723" cy="1627427"/>
+            <a:off x="2705592" y="4652253"/>
+            <a:ext cx="3677723" cy="1627428"/>
           </a:xfrm>
           <a:prstGeom prst="rect">
             <a:avLst/>
@@ -4366,7 +5470,7 @@
         </p:blipFill>
         <p:spPr>
           <a:xfrm>
-            <a:off x="6383313" y="4677377"/>
+            <a:off x="6383313" y="4677378"/>
             <a:ext cx="2766700" cy="1602302"/>
           </a:xfrm>
           <a:prstGeom prst="rect">
@@ -4396,7 +5500,7 @@
         </p:blipFill>
         <p:spPr>
           <a:xfrm>
-            <a:off x="9153526" y="4677379"/>
+            <a:off x="9153526" y="4677380"/>
             <a:ext cx="2766700" cy="1602302"/>
           </a:xfrm>
           <a:prstGeom prst="rect">
@@ -4456,8 +5560,8 @@
         </p:blipFill>
         <p:spPr>
           <a:xfrm>
-            <a:off x="0" y="608929"/>
-            <a:ext cx="12192000" cy="5640141"/>
+            <a:off x="0" y="608932"/>
+            <a:ext cx="12192000" cy="5640140"/>
           </a:xfrm>
           <a:prstGeom prst="rect">
             <a:avLst/>
@@ -4479,7 +5583,7 @@
         <p:spPr>
           <a:xfrm>
             <a:off x="2285999" y="6371303"/>
-            <a:ext cx="6504473" cy="276999"/>
+            <a:ext cx="6565387" cy="276999"/>
           </a:xfrm>
           <a:prstGeom prst="rect">
             <a:avLst/>
@@ -4517,8 +5621,8 @@
         </p:nvSpPr>
         <p:spPr>
           <a:xfrm>
-            <a:off x="2485103" y="5715000"/>
-            <a:ext cx="3610897" cy="427703"/>
+            <a:off x="2485104" y="5715001"/>
+            <a:ext cx="3610898" cy="427703"/>
           </a:xfrm>
           <a:prstGeom prst="roundRect">
             <a:avLst/>
@@ -4551,7 +5655,7 @@
           <a:lstStyle/>
           <a:p>
             <a:pPr algn="ctr"/>
-            <a:endParaRPr lang="es-PE"/>
+            <a:endParaRPr lang="es-PE" sz="1801"/>
           </a:p>
         </p:txBody>
       </p:sp>
@@ -4569,8 +5673,8 @@
         </p:nvCxnSpPr>
         <p:spPr>
           <a:xfrm flipH="1" flipV="1">
-            <a:off x="4837471" y="6142703"/>
-            <a:ext cx="140110" cy="228600"/>
+            <a:off x="4837470" y="6142703"/>
+            <a:ext cx="140110" cy="228601"/>
           </a:xfrm>
           <a:prstGeom prst="straightConnector1">
             <a:avLst/>
@@ -4611,7 +5715,7 @@
         </p:nvCxnSpPr>
         <p:spPr>
           <a:xfrm>
-            <a:off x="2485103" y="2847975"/>
+            <a:off x="2485102" y="2847974"/>
             <a:ext cx="7258972" cy="0"/>
           </a:xfrm>
           <a:prstGeom prst="straightConnector1">
@@ -4654,8 +5758,8 @@
         </p:nvSpPr>
         <p:spPr>
           <a:xfrm>
-            <a:off x="70885" y="3013500"/>
-            <a:ext cx="2115229" cy="461665"/>
+            <a:off x="70886" y="3013500"/>
+            <a:ext cx="2115228" cy="461665"/>
           </a:xfrm>
           <a:prstGeom prst="rect">
             <a:avLst/>
@@ -4695,8 +5799,8 @@
         </p:nvCxnSpPr>
         <p:spPr>
           <a:xfrm flipV="1">
-            <a:off x="1962150" y="2891268"/>
-            <a:ext cx="1771650" cy="353064"/>
+            <a:off x="1962150" y="2891269"/>
+            <a:ext cx="1771650" cy="353065"/>
           </a:xfrm>
           <a:prstGeom prst="straightConnector1">
             <a:avLst/>
@@ -4737,8 +5841,8 @@
         </p:nvSpPr>
         <p:spPr>
           <a:xfrm>
-            <a:off x="0" y="3787168"/>
-            <a:ext cx="2115229" cy="830997"/>
+            <a:off x="0" y="3787170"/>
+            <a:ext cx="2115228" cy="830997"/>
           </a:xfrm>
           <a:prstGeom prst="rect">
             <a:avLst/>
@@ -4776,8 +5880,8 @@
         </p:nvSpPr>
         <p:spPr>
           <a:xfrm>
-            <a:off x="818228" y="5075802"/>
-            <a:ext cx="962947" cy="324874"/>
+            <a:off x="818227" y="5075802"/>
+            <a:ext cx="962948" cy="324875"/>
           </a:xfrm>
           <a:prstGeom prst="roundRect">
             <a:avLst/>
@@ -4810,7 +5914,7 @@
           <a:lstStyle/>
           <a:p>
             <a:pPr algn="ctr"/>
-            <a:endParaRPr lang="es-PE"/>
+            <a:endParaRPr lang="es-PE" sz="1801"/>
           </a:p>
         </p:txBody>
       </p:sp>
@@ -4830,8 +5934,8 @@
         </p:nvCxnSpPr>
         <p:spPr>
           <a:xfrm>
-            <a:off x="1128499" y="4502750"/>
-            <a:ext cx="328826" cy="573052"/>
+            <a:off x="1128500" y="4502750"/>
+            <a:ext cx="328827" cy="573052"/>
           </a:xfrm>
           <a:prstGeom prst="straightConnector1">
             <a:avLst/>
@@ -4872,8 +5976,8 @@
         </p:nvSpPr>
         <p:spPr>
           <a:xfrm>
-            <a:off x="818228" y="1162874"/>
-            <a:ext cx="2115229" cy="276999"/>
+            <a:off x="818230" y="1162875"/>
+            <a:ext cx="2115228" cy="276999"/>
           </a:xfrm>
           <a:prstGeom prst="rect">
             <a:avLst/>
@@ -4913,8 +6017,8 @@
         </p:nvCxnSpPr>
         <p:spPr>
           <a:xfrm flipH="1" flipV="1">
-            <a:off x="609600" y="925226"/>
-            <a:ext cx="208628" cy="335137"/>
+            <a:off x="609601" y="925227"/>
+            <a:ext cx="208628" cy="335138"/>
           </a:xfrm>
           <a:prstGeom prst="straightConnector1">
             <a:avLst/>
@@ -4955,7 +6059,7 @@
         </p:nvSpPr>
         <p:spPr>
           <a:xfrm>
-            <a:off x="85142" y="675389"/>
+            <a:off x="85143" y="675390"/>
             <a:ext cx="514933" cy="388830"/>
           </a:xfrm>
           <a:prstGeom prst="roundRect">
@@ -4989,7 +6093,7 @@
           <a:lstStyle/>
           <a:p>
             <a:pPr algn="ctr"/>
-            <a:endParaRPr lang="es-PE"/>
+            <a:endParaRPr lang="es-PE" sz="1801"/>
           </a:p>
         </p:txBody>
       </p:sp>
@@ -5007,8 +6111,8 @@
         </p:nvSpPr>
         <p:spPr>
           <a:xfrm>
-            <a:off x="2323517" y="877388"/>
-            <a:ext cx="1295983" cy="388830"/>
+            <a:off x="2323518" y="877389"/>
+            <a:ext cx="1295982" cy="388830"/>
           </a:xfrm>
           <a:prstGeom prst="roundRect">
             <a:avLst/>
@@ -5041,7 +6145,7 @@
           <a:lstStyle/>
           <a:p>
             <a:pPr algn="ctr"/>
-            <a:endParaRPr lang="es-PE"/>
+            <a:endParaRPr lang="es-PE" sz="1801"/>
           </a:p>
         </p:txBody>
       </p:sp>
@@ -5061,8 +6165,8 @@
         </p:nvCxnSpPr>
         <p:spPr>
           <a:xfrm flipH="1">
-            <a:off x="3647371" y="486696"/>
-            <a:ext cx="1009528" cy="383109"/>
+            <a:off x="3647371" y="486697"/>
+            <a:ext cx="1009529" cy="383109"/>
           </a:xfrm>
           <a:prstGeom prst="straightConnector1">
             <a:avLst/>
@@ -5103,7 +6207,7 @@
         </p:nvSpPr>
         <p:spPr>
           <a:xfrm>
-            <a:off x="3878449" y="166405"/>
+            <a:off x="3878451" y="166405"/>
             <a:ext cx="990977" cy="276999"/>
           </a:xfrm>
           <a:prstGeom prst="rect">
@@ -5142,8 +6246,8 @@
         </p:nvGrpSpPr>
         <p:grpSpPr>
           <a:xfrm>
-            <a:off x="4733271" y="-19049"/>
-            <a:ext cx="1381318" cy="614816"/>
+            <a:off x="4733272" y="-19050"/>
+            <a:ext cx="1381317" cy="614816"/>
             <a:chOff x="5405341" y="3052342"/>
             <a:chExt cx="1381318" cy="614816"/>
           </a:xfrm>
@@ -5231,7 +6335,7 @@
         </p:nvSpPr>
         <p:spPr>
           <a:xfrm>
-            <a:off x="6242471" y="166405"/>
+            <a:off x="6242472" y="166405"/>
             <a:ext cx="4673179" cy="461665"/>
           </a:xfrm>
           <a:prstGeom prst="rect">
@@ -5308,7 +6412,7 @@
         </p:blipFill>
         <p:spPr>
           <a:xfrm>
-            <a:off x="478258" y="3412"/>
+            <a:off x="478259" y="3413"/>
             <a:ext cx="10863351" cy="6858000"/>
           </a:xfrm>
           <a:prstGeom prst="rect">
@@ -5330,8 +6434,8 @@
         </p:nvSpPr>
         <p:spPr>
           <a:xfrm>
-            <a:off x="1201003" y="187657"/>
-            <a:ext cx="2606722" cy="358253"/>
+            <a:off x="1201003" y="187659"/>
+            <a:ext cx="2606722" cy="358252"/>
           </a:xfrm>
           <a:prstGeom prst="roundRect">
             <a:avLst/>
@@ -5364,7 +6468,7 @@
           <a:lstStyle/>
           <a:p>
             <a:pPr algn="ctr"/>
-            <a:endParaRPr lang="es-PE"/>
+            <a:endParaRPr lang="es-PE" sz="1801"/>
           </a:p>
         </p:txBody>
       </p:sp>
@@ -5382,8 +6486,8 @@
         </p:nvSpPr>
         <p:spPr>
           <a:xfrm>
-            <a:off x="6269048" y="84245"/>
-            <a:ext cx="2115229" cy="369332"/>
+            <a:off x="6269049" y="84247"/>
+            <a:ext cx="2115228" cy="369332"/>
           </a:xfrm>
           <a:prstGeom prst="rect">
             <a:avLst/>
@@ -5423,8 +6527,8 @@
         </p:nvCxnSpPr>
         <p:spPr>
           <a:xfrm flipH="1">
-            <a:off x="3807726" y="187657"/>
-            <a:ext cx="2461322" cy="0"/>
+            <a:off x="3807726" y="187658"/>
+            <a:ext cx="2461323" cy="0"/>
           </a:xfrm>
           <a:prstGeom prst="straightConnector1">
             <a:avLst/>
@@ -5465,8 +6569,8 @@
         </p:nvSpPr>
         <p:spPr>
           <a:xfrm>
-            <a:off x="6096001" y="516290"/>
-            <a:ext cx="2461322" cy="400110"/>
+            <a:off x="6096000" y="516292"/>
+            <a:ext cx="2461323" cy="400366"/>
           </a:xfrm>
           <a:prstGeom prst="rect">
             <a:avLst/>
@@ -5480,7 +6584,7 @@
           <a:lstStyle/>
           <a:p>
             <a:r>
-              <a:rPr lang="es-PE" sz="1000" b="1" dirty="0">
+              <a:rPr lang="es-PE" sz="1001" b="1" dirty="0">
                 <a:solidFill>
                   <a:schemeClr val="bg1"/>
                 </a:solidFill>
@@ -5504,8 +6608,8 @@
         </p:nvSpPr>
         <p:spPr>
           <a:xfrm>
-            <a:off x="6404403" y="1677330"/>
-            <a:ext cx="2906575" cy="461665"/>
+            <a:off x="6404404" y="1677332"/>
+            <a:ext cx="2906574" cy="461665"/>
           </a:xfrm>
           <a:prstGeom prst="rect">
             <a:avLst/>
@@ -5546,8 +6650,8 @@
         </p:nvCxnSpPr>
         <p:spPr>
           <a:xfrm flipH="1" flipV="1">
-            <a:off x="4858247" y="516290"/>
-            <a:ext cx="1237754" cy="200055"/>
+            <a:off x="4858252" y="516294"/>
+            <a:ext cx="1237748" cy="200181"/>
           </a:xfrm>
           <a:prstGeom prst="straightConnector1">
             <a:avLst/>
@@ -5590,8 +6694,8 @@
         </p:nvCxnSpPr>
         <p:spPr>
           <a:xfrm flipH="1" flipV="1">
-            <a:off x="5568287" y="1583137"/>
-            <a:ext cx="836116" cy="232015"/>
+            <a:off x="5568289" y="1583139"/>
+            <a:ext cx="836116" cy="232014"/>
           </a:xfrm>
           <a:prstGeom prst="straightConnector1">
             <a:avLst/>
@@ -5632,8 +6736,8 @@
         </p:nvSpPr>
         <p:spPr>
           <a:xfrm>
-            <a:off x="627797" y="967856"/>
-            <a:ext cx="10413242" cy="615281"/>
+            <a:off x="627798" y="967857"/>
+            <a:ext cx="10413243" cy="615282"/>
           </a:xfrm>
           <a:prstGeom prst="roundRect">
             <a:avLst/>
@@ -5666,7 +6770,7 @@
           <a:lstStyle/>
           <a:p>
             <a:pPr algn="ctr"/>
-            <a:endParaRPr lang="es-PE"/>
+            <a:endParaRPr lang="es-PE" sz="1801"/>
           </a:p>
         </p:txBody>
       </p:sp>
@@ -5722,8 +6826,8 @@
         </p:blipFill>
         <p:spPr>
           <a:xfrm>
-            <a:off x="0" y="602713"/>
-            <a:ext cx="12192000" cy="5652573"/>
+            <a:off x="0" y="602714"/>
+            <a:ext cx="12192000" cy="5652572"/>
           </a:xfrm>
           <a:prstGeom prst="rect">
             <a:avLst/>
@@ -5745,7 +6849,7 @@
         <p:spPr>
           <a:xfrm>
             <a:off x="2471596" y="2233741"/>
-            <a:ext cx="1312753" cy="265920"/>
+            <a:ext cx="1312754" cy="265920"/>
           </a:xfrm>
           <a:prstGeom prst="roundRect">
             <a:avLst/>
@@ -5778,7 +6882,7 @@
           <a:lstStyle/>
           <a:p>
             <a:pPr algn="ctr"/>
-            <a:endParaRPr lang="es-PE"/>
+            <a:endParaRPr lang="es-PE" sz="1801"/>
           </a:p>
         </p:txBody>
       </p:sp>
@@ -5796,8 +6900,8 @@
         </p:nvSpPr>
         <p:spPr>
           <a:xfrm>
-            <a:off x="7165341" y="2130329"/>
-            <a:ext cx="2115229" cy="369332"/>
+            <a:off x="7165342" y="2130331"/>
+            <a:ext cx="2115228" cy="369332"/>
           </a:xfrm>
           <a:prstGeom prst="rect">
             <a:avLst/>
@@ -5837,8 +6941,8 @@
         </p:nvCxnSpPr>
         <p:spPr>
           <a:xfrm flipH="1">
-            <a:off x="3784349" y="2233740"/>
-            <a:ext cx="3380992" cy="1"/>
+            <a:off x="3784348" y="2233740"/>
+            <a:ext cx="3380992" cy="2"/>
           </a:xfrm>
           <a:prstGeom prst="straightConnector1">
             <a:avLst/>
@@ -5918,7 +7022,7 @@
         <p:spPr>
           <a:xfrm>
             <a:off x="0" y="617868"/>
-            <a:ext cx="12192000" cy="5622264"/>
+            <a:ext cx="12192000" cy="5622265"/>
           </a:xfrm>
           <a:prstGeom prst="rect">
             <a:avLst/>
@@ -5939,8 +7043,8 @@
         </p:nvSpPr>
         <p:spPr>
           <a:xfrm>
-            <a:off x="5840438" y="4383383"/>
-            <a:ext cx="2758130" cy="252771"/>
+            <a:off x="5840437" y="4383384"/>
+            <a:ext cx="2758130" cy="252772"/>
           </a:xfrm>
           <a:prstGeom prst="roundRect">
             <a:avLst/>
@@ -5973,7 +7077,7 @@
           <a:lstStyle/>
           <a:p>
             <a:pPr algn="ctr"/>
-            <a:endParaRPr lang="es-PE"/>
+            <a:endParaRPr lang="es-PE" sz="1801"/>
           </a:p>
         </p:txBody>
       </p:sp>
@@ -5991,7 +7095,7 @@
         </p:nvSpPr>
         <p:spPr>
           <a:xfrm>
-            <a:off x="8807116" y="5189439"/>
+            <a:off x="8807117" y="5189439"/>
             <a:ext cx="2909168" cy="507831"/>
           </a:xfrm>
           <a:prstGeom prst="rect">
@@ -6032,8 +7136,8 @@
         </p:nvCxnSpPr>
         <p:spPr>
           <a:xfrm flipH="1" flipV="1">
-            <a:off x="7042485" y="4636154"/>
-            <a:ext cx="1764631" cy="737951"/>
+            <a:off x="7042486" y="4636157"/>
+            <a:ext cx="1764631" cy="737950"/>
           </a:xfrm>
           <a:prstGeom prst="straightConnector1">
             <a:avLst/>
@@ -6112,8 +7216,8 @@
         </p:blipFill>
         <p:spPr>
           <a:xfrm>
-            <a:off x="3566759" y="518706"/>
-            <a:ext cx="5058481" cy="5820587"/>
+            <a:off x="3566759" y="518707"/>
+            <a:ext cx="5058482" cy="5820587"/>
           </a:xfrm>
           <a:prstGeom prst="rect">
             <a:avLst/>
@@ -6134,8 +7238,8 @@
         </p:nvSpPr>
         <p:spPr>
           <a:xfrm>
-            <a:off x="4247707" y="818707"/>
-            <a:ext cx="632637" cy="382772"/>
+            <a:off x="4247709" y="818707"/>
+            <a:ext cx="632636" cy="382772"/>
           </a:xfrm>
           <a:prstGeom prst="rect">
             <a:avLst/>
@@ -6168,7 +7272,7 @@
           <a:lstStyle/>
           <a:p>
             <a:pPr algn="ctr"/>
-            <a:endParaRPr lang="es-PE"/>
+            <a:endParaRPr lang="es-PE" sz="1801"/>
           </a:p>
         </p:txBody>
       </p:sp>
@@ -6222,7 +7326,7 @@
         </p:nvSpPr>
         <p:spPr>
           <a:xfrm>
-            <a:off x="6945223" y="818707"/>
+            <a:off x="6945224" y="818707"/>
             <a:ext cx="1302871" cy="382772"/>
           </a:xfrm>
           <a:prstGeom prst="rect">
@@ -6256,7 +7360,7 @@
           <a:lstStyle/>
           <a:p>
             <a:pPr algn="ctr"/>
-            <a:endParaRPr lang="es-PE"/>
+            <a:endParaRPr lang="es-PE" sz="1801"/>
           </a:p>
         </p:txBody>
       </p:sp>
@@ -6283,7 +7387,7 @@
         <p:spPr>
           <a:xfrm>
             <a:off x="7303554" y="866771"/>
-            <a:ext cx="651704" cy="286643"/>
+            <a:ext cx="651705" cy="286644"/>
           </a:xfrm>
           <a:prstGeom prst="rect">
             <a:avLst/>
@@ -6304,7 +7408,7 @@
         </p:nvSpPr>
         <p:spPr>
           <a:xfrm>
-            <a:off x="7379459" y="771125"/>
+            <a:off x="7379460" y="771125"/>
             <a:ext cx="575799" cy="169277"/>
           </a:xfrm>
           <a:prstGeom prst="rect">
@@ -6351,7 +7455,7 @@
         <p:spPr>
           <a:xfrm>
             <a:off x="6407045" y="2813736"/>
-            <a:ext cx="4458322" cy="5639587"/>
+            <a:ext cx="4458322" cy="5639588"/>
           </a:xfrm>
           <a:prstGeom prst="rect">
             <a:avLst/>
@@ -6380,8 +7484,8 @@
         </p:blipFill>
         <p:spPr>
           <a:xfrm>
-            <a:off x="4247707" y="5058368"/>
-            <a:ext cx="3707551" cy="384705"/>
+            <a:off x="4247709" y="5058370"/>
+            <a:ext cx="3707550" cy="384706"/>
           </a:xfrm>
           <a:prstGeom prst="rect">
             <a:avLst/>
@@ -6402,8 +7506,8 @@
         </p:nvSpPr>
         <p:spPr>
           <a:xfrm>
-            <a:off x="4207973" y="4493994"/>
-            <a:ext cx="3791944" cy="424698"/>
+            <a:off x="4207974" y="4493995"/>
+            <a:ext cx="3791945" cy="424699"/>
           </a:xfrm>
           <a:prstGeom prst="rect">
             <a:avLst/>
@@ -6436,7 +7540,7 @@
           <a:lstStyle/>
           <a:p>
             <a:pPr algn="ctr"/>
-            <a:endParaRPr lang="es-PE"/>
+            <a:endParaRPr lang="es-PE" sz="1801"/>
           </a:p>
         </p:txBody>
       </p:sp>

</xml_diff>